<commit_message>
feat(platformer-v2): mobile port with sound, lives, level 2 and PC installer
- 2D-Platformer-Unity-v2: Input System + on-screen controls, landscape,
  safe area; ground check fix (R-PLT-09, DEC-LAB-015); synthesized SFX
  (coin, jump, death); 3 lives with Game Over (DEC-LAB-016); Level2 with
  wider pits and patrolling enemies; Android APK + Windows Inno Setup
  installer via Tools/generar_builds.ps1. Tests: EditMode 15/15, PlayMode 17/17.
- laboratorio-adaptacion: PORTEO-PLATFORMER.md, decisions, evidence logs.
- unidad-04: before/after slides (PC and Android) in the source and v2 deck.
- CONTINUAR.md: build and short-path rules; other pending workspace files.

Co-Authored-By: Claude Opus 5.5 <noreply@anthropic.com>
</commit_message>
<xml_diff>
--- a/diseno-plataformas/unidad-04/Unidad-4-2026-completa.pptx
+++ b/diseno-plataformas/unidad-04/Unidad-4-2026-completa.pptx
@@ -68,6 +68,8 @@
     <p:sldId id="316" r:id="rId68"/>
     <p:sldId id="317" r:id="rId69"/>
     <p:sldId id="318" r:id="rId70"/>
+    <p:sldId id="319" r:id="rId71"/>
+    <p:sldId id="320" r:id="rId72"/>
   </p:sldIdLst>
   <p:sldSz cx="12191695" cy="6858000" type="screen4x3"/>
   <p:notesSz cx="6858000" cy="9144000"/>
@@ -5177,6 +5179,56 @@
               <a:t>Imagen sugerida (opcional, sin recuadro en la slide): titular del comunicado oficial de la FTC del 19/12/2022.</a:t>
             </a:r>
           </a:p>
+          <a:p>
+            <a:r>
+              <a:t>• ACM (Autoriteit Consument &amp; Markt): autoridad de consumo y competencia de los Países Bajos.</a:t>
+            </a:r>
+          </a:p>
+          <a:p>
+            <a:r>
+              <a:t>• Item Shop: la tienda de objetos dentro de Fortnite.</a:t>
+            </a:r>
+          </a:p>
+          <a:p>
+            <a:r>
+              <a:t>No es un caso aislado: en 2024 la ACM multó a Epic con 1.125.000 euros en total, más una orden obligatoria de cambiar la tienda, por prácticas comerciales desleales dirigidas a niños en el Item Shop de Fortnite (mensajes del tipo "consíguelo ya" y temporizadores de cuenta regresiva engañosos). Epic recurrió y el 14/01/2026 el Tribunal de Distrito de Róterdam le dio la razón a la ACM: "Epic directly exhorted children to make purchases in the Fortnite Item Shop" (ACM, "Ruling of the District Court of Rotterdam: Epic's objection declared unfounded", 14/01/2026, https://www.acm.nl/en/node/28730). Epic no discutió la infracción de los temporizadores.</a:t>
+            </a:r>
+          </a:p>
+          <a:p>
+            <a:r>
+              <a:t>Para remarcar: dos países, dos organismos y la misma conclusión: la pantalla de compra es diseño, y el diseño tiene consecuencias legales. El temporizador que apura es una decisión de interfaz, igual que el botón confuso.</a:t>
+            </a:r>
+          </a:p>
+          <a:p>
+            <a:r>
+              <a:t>Videos cortos de noticias, en español (pedido de la titular, 2026-10-19), para abrir el tema:</a:t>
+            </a:r>
+          </a:p>
+          <a:p>
+            <a:r>
+              <a:t>- La Tercera (Chile), "Millonaria multa: no fue una 'victoria magistral' para Epic Games", caso FTC: https://www.facebook.com/watch/?v=2465461220269942</a:t>
+            </a:r>
+          </a:p>
+          <a:p>
+            <a:r>
+              <a:t>- El Deber (Bolivia), "Multa millonaria a Fortnite por violar la privacidad de menores y manipulación", caso FTC: https://www.facebook.com/watch/?v=541682641335363</a:t>
+            </a:r>
+          </a:p>
+          <a:p>
+            <a:r>
+              <a:t>- El Sol de México, multa de Países Bajos por prácticas desleales con menores: https://www.facebook.com/reel/657601210708360</a:t>
+            </a:r>
+          </a:p>
+          <a:p>
+            <a:r>
+              <a:t>- DW Español, "Fortnite pagará USD 520 millones por violar privacidad de menores" (12 min, 19/12/2022): https://www.youtube.com/watch?v=cavSjjSDdo0</a:t>
+            </a:r>
+          </a:p>
+          <a:p>
+            <a:r>
+              <a:t>Verificación (2026-10-19): título y medio de los tres videos de Facebook leídos de los metadatos públicos de cada enlace; el reel de El Sol de México no muestra título, solo la descripción. Facebook puede pedir iniciar sesión para reproducirlos: probarlos antes de la clase. El video de DW se verificó en YouTube (título, canal, fecha y duración). No se miraron completos.</a:t>
+            </a:r>
+          </a:p>
         </p:txBody>
       </p:sp>
       <p:sp>
@@ -6437,6 +6489,21 @@
               <a:t>No detenerse más de 3 minutos: es contexto, no contenido evaluable.</a:t>
             </a:r>
           </a:p>
+          <a:p>
+            <a:r>
+              <a:t>Videos de consulta, en español (agregados el 2026-10-19; existencia, título, canal y fecha verificados con YouTube el 2026-10-19; el contenido no se revisó completo):</a:t>
+            </a:r>
+          </a:p>
+          <a:p>
+            <a:r>
+              <a:t>- lucasmelor, "La historia COMPLETA de los Juegos de Celular" (21 min, 24/02/2025): https://www.youtube.com/watch?v=kEwd_CnXvaM. Canal de divulgación, no académico; incluye un segmento patrocinado.</a:t>
+            </a:r>
+          </a:p>
+          <a:p>
+            <a:r>
+              <a:t>- Aranimations ES y Cerebro Sin hueso, "Antes de las App Stores: Así Era el Increíble Gaming en Celulares Java" (9 min, 12/09/2026): https://www.youtube.com/watch?v=omq5avbt8kw. Muestra la etapa previa a 2008 (Snake, J2ME, Gameloft): el teléfono ya era plataforma de juego antes del App Store, que es el hito que usa la cronología.</a:t>
+            </a:r>
+          </a:p>
         </p:txBody>
       </p:sp>
       <p:sp>
@@ -6722,6 +6789,31 @@
               <a:t>Tiempo de referencia: Mono + ARMv7, 42 s y 20 MB en la PC de la docente (2026-10-12). Con IL2CPP la primera build tarda bastante más (no medido todavía).</a:t>
             </a:r>
           </a:p>
+          <a:p>
+            <a:r>
+              <a:t>Videos de ejemplo, en español (agregados el 2026-10-19; título, canal, fecha y descripción verificados con YouTube el 2026-10-19; no se miraron completos ni se compararon paso por paso con este anexo):</a:t>
+            </a:r>
+          </a:p>
+          <a:p>
+            <a:r>
+              <a:t>- Jadsa Games, "De PC a Android: Guía Completa para Portear y Publicar tu Juego con Unity 6" (18 min, 26/11/2025): https://www.youtube.com/watch?v=BuaJrjBDxK8. Es el que más se parece a la unidad: toma un juego de PC, agrega botones táctiles, ajusta la relación de aspecto y genera el APK y el .aab. Llega hasta la publicación en Google Play, que en esta materia no se hace.</a:t>
+            </a:r>
+          </a:p>
+          <a:p>
+            <a:r>
+              <a:t>- LuisCanary, "Generar EJECUTABLE de tu Videojuego en UNITY | Sacar .EXE y .APK (PC y Android)" (13 min, 26/02/2026): https://www.youtube.com/watch?v=nlgC6N_xfpM. Muestra la misma build para PC y para Android, útil para comparar los dos destinos. La descripción no dice la versión de Unity: si los menús no coinciden, seguir este anexo (Unity 6000.3.11f1).</a:t>
+            </a:r>
+          </a:p>
+          <a:p>
+            <a:r>
+              <a:t>- Complemento, del mismo canal que el primero: Jadsa Games, "Crear un Bundle .AAB para Android en Unity 6" (8 min): https://www.youtube.com/watch?v=COrg93Kz4o0.</a:t>
+            </a:r>
+          </a:p>
+          <a:p>
+            <a:r>
+              <a:t>Diferencia a remarcar: los videos que publican en Google Play generan .aab (Build App Bundle tildado). Para probar en el teléfono, esta unidad usa .apk (casilla destildada, paso 4).</a:t>
+            </a:r>
+          </a:p>
         </p:txBody>
       </p:sp>
       <p:sp>
@@ -6829,6 +6921,236 @@
 </p:notes>
 </file>
 
+<file path=ppt/notesSlides/notesSlide64.xml><?xml version="1.0" encoding="utf-8"?>
+<p:notes xmlns:a="http://schemas.openxmlformats.org/drawingml/2006/main" xmlns:p="http://schemas.openxmlformats.org/presentationml/2006/main" xmlns:r="http://schemas.openxmlformats.org/officeDocument/2006/relationships">
+  <p:cSld>
+    <p:spTree>
+      <p:nvGrpSpPr>
+        <p:cNvPr id="1" name=""/>
+        <p:cNvGrpSpPr/>
+        <p:nvPr/>
+      </p:nvGrpSpPr>
+      <p:grpSpPr>
+        <a:xfrm>
+          <a:off x="0" y="0"/>
+          <a:ext cx="0" cy="0"/>
+          <a:chOff x="0" y="0"/>
+          <a:chExt cx="0" cy="0"/>
+        </a:xfrm>
+      </p:grpSpPr>
+      <p:sp>
+        <p:nvSpPr>
+          <p:cNvPr id="2" name="Slide Image Placeholder 1"/>
+          <p:cNvSpPr>
+            <a:spLocks noGrp="1"/>
+          </p:cNvSpPr>
+          <p:nvPr>
+            <p:ph type="sldImg" idx="2"/>
+          </p:nvPr>
+        </p:nvSpPr>
+        <p:spPr/>
+      </p:sp>
+      <p:sp>
+        <p:nvSpPr>
+          <p:cNvPr id="3" name="Notes Placeholder 2"/>
+          <p:cNvSpPr>
+            <a:spLocks noGrp="1"/>
+          </p:cNvSpPr>
+          <p:nvPr>
+            <p:ph type="body" idx="3" sz="quarter"/>
+          </p:nvPr>
+        </p:nvSpPr>
+        <p:spPr/>
+        <p:txBody>
+          <a:bodyPr/>
+          <a:lstStyle/>
+          <a:p>
+            <a:r>
+              <a:t>Glosario (conceptos cortos para la docente):</a:t>
+            </a:r>
+          </a:p>
+          <a:p>
+            <a:r>
+              <a:t>• Input Manager (legacy): sistema de entrada clásico de Unity; los ejes y botones se configuran en Project Settings &gt; Input Manager.</a:t>
+            </a:r>
+          </a:p>
+          <a:p>
+            <a:r>
+              <a:t>• Gamepad virtual: los botones en pantalla (OnScreenButton) se hacen pasar por un gamepad; el juego no distingue el dedo de un control físico.</a:t>
+            </a:r>
+          </a:p>
+          <a:p>
+            <a:r>
+              <a:t>• Safe area: parte de la pantalla libre de muesca y barra de gestos.</a:t>
+            </a:r>
+          </a:p>
+          <a:p>
+            <a:r>
+              <a:t>• Suavizado: el eje "Horizontal" del Input Manager acelera y frena en unos 0,3 s en lugar de saltar de 0 a 1.</a:t>
+            </a:r>
+          </a:p>
+          <a:p>
+            <a:r>
+              <a:t>Qué muestra: el mismo juego (2D Platformer, el segundo caso del laboratorio) antes y después del porteo, en las dos plataformas. La versión 2 es una copia; el original no se tocó.</a:t>
+            </a:r>
+          </a:p>
+          <a:p>
+            <a:r>
+              <a:t>PC antes: teclado (flechas o A/D, salto con Espacio) y un joystick genérico configurado en el Input Manager (el salto del joystick era "joystick button 3", que en un control de Xbox es Y, no A). PC después: las mismas teclas, más gamepad (stick, cruceta y botón A para saltar).</a:t>
+            </a:r>
+          </a:p>
+          <a:p>
+            <a:r>
+              <a:t>Android antes: el juego tenía un campo "controlmode" y un contenedor MobileControls, pero el contenedor estaba vacío; en el teléfono se podía tocar el menú, pero el personaje no se movía. Android después: botones ◀ ▶ y SALTAR, visibles solo en móvil; mantener ◀ mueve de forma continua y soltar detiene. Orientación: solo horizontal, porque es un juego de desplazamiento lateral.</a:t>
+            </a:r>
+          </a:p>
+          <a:p>
+            <a:r>
+              <a:t>Respuesta esperada a la pregunta: casi nada, y eso es lo buscado. Dos diferencias reales: ahora responde a un gamepad moderno, y el movimiento con teclado ya no tiene suavizado (respuesta inmediata). Es un cambio de sensación: hay que contarlo, no esconderlo.</a:t>
+            </a:r>
+          </a:p>
+          <a:p>
+            <a:r>
+              <a:t>Qué NO resuelve esto: el esquema táctil (botones o stick) es provisional y lo eligen los grupos; no hay coyote time ni buffer de salto; no se probó todavía en un teléfono real.</a:t>
+            </a:r>
+          </a:p>
+        </p:txBody>
+      </p:sp>
+      <p:sp>
+        <p:nvSpPr>
+          <p:cNvPr id="4" name="Slide Number Placeholder 3"/>
+          <p:cNvSpPr>
+            <a:spLocks noGrp="1"/>
+          </p:cNvSpPr>
+          <p:nvPr>
+            <p:ph type="sldNum" idx="5" sz="quarter"/>
+          </p:nvPr>
+        </p:nvSpPr>
+        <p:spPr/>
+      </p:sp>
+    </p:spTree>
+  </p:cSld>
+  <p:clrMapOvr>
+    <a:masterClrMapping/>
+  </p:clrMapOvr>
+</p:notes>
+</file>
+
+<file path=ppt/notesSlides/notesSlide65.xml><?xml version="1.0" encoding="utf-8"?>
+<p:notes xmlns:a="http://schemas.openxmlformats.org/drawingml/2006/main" xmlns:p="http://schemas.openxmlformats.org/presentationml/2006/main" xmlns:r="http://schemas.openxmlformats.org/officeDocument/2006/relationships">
+  <p:cSld>
+    <p:spTree>
+      <p:nvGrpSpPr>
+        <p:cNvPr id="1" name=""/>
+        <p:cNvGrpSpPr/>
+        <p:nvPr/>
+      </p:nvGrpSpPr>
+      <p:grpSpPr>
+        <a:xfrm>
+          <a:off x="0" y="0"/>
+          <a:ext cx="0" cy="0"/>
+          <a:chOff x="0" y="0"/>
+          <a:chExt cx="0" cy="0"/>
+        </a:xfrm>
+      </p:grpSpPr>
+      <p:sp>
+        <p:nvSpPr>
+          <p:cNvPr id="2" name="Slide Image Placeholder 1"/>
+          <p:cNvSpPr>
+            <a:spLocks noGrp="1"/>
+          </p:cNvSpPr>
+          <p:nvPr>
+            <p:ph type="sldImg" idx="2"/>
+          </p:nvPr>
+        </p:nvSpPr>
+        <p:spPr/>
+      </p:sp>
+      <p:sp>
+        <p:nvSpPr>
+          <p:cNvPr id="3" name="Notes Placeholder 2"/>
+          <p:cNvSpPr>
+            <a:spLocks noGrp="1"/>
+          </p:cNvSpPr>
+          <p:nvPr>
+            <p:ph type="body" idx="3" sz="quarter"/>
+          </p:nvPr>
+        </p:nvSpPr>
+        <p:spPr/>
+        <p:txBody>
+          <a:bodyPr/>
+          <a:lstStyle/>
+          <a:p>
+            <a:r>
+              <a:t>Glosario (conceptos cortos para la docente):</a:t>
+            </a:r>
+          </a:p>
+          <a:p>
+            <a:r>
+              <a:t>• Input System: paquete de entrada moderno de Unity; unifica teclado, gamepad y táctil.</a:t>
+            </a:r>
+          </a:p>
+          <a:p>
+            <a:r>
+              <a:t>• SetIntent: método del jugador que recibe la intención (mover, saltar) sin saber de qué dispositivo vino.</a:t>
+            </a:r>
+          </a:p>
+          <a:p>
+            <a:r>
+              <a:t>• Módulo de UI: componente del EventSystem que traduce clics y toques a eventos de botones.</a:t>
+            </a:r>
+          </a:p>
+          <a:p>
+            <a:r>
+              <a:t>• URP en modo compatibilidad: modo viejo del render de Unity; Unity 6.3 no compila builds con él activado.</a:t>
+            </a:r>
+          </a:p>
+          <a:p>
+            <a:r>
+              <a:t>Fila por fila: el input pasó del Input Manager al Input System, configurado solo en "New" porque Unity 6.3 no admite "Both" en Android. El PlayerController ya no lee teclas: un adaptador lee el dispositivo y le pasa la intención. Los menús cambiaron de módulo de UI para funcionar sin el sistema viejo.</a:t>
+            </a:r>
+          </a:p>
+          <a:p>
+            <a:r>
+              <a:t>Errores y build: el error "isGrounded" se repetía en cada frame (2447 veces en una sesión) y ahora aparece 0 veces. La build de Android del proyecto migrado fallaba por el render en modo compatibilidad; corregido eso, generó un APK de 35,9 MB (Mono, ARMv7, 9 min 25 s la primera vez).</a:t>
+            </a:r>
+          </a:p>
+          <a:p>
+            <a:r>
+              <a:t>Tests: 6 de configuración (Edit Mode) y 10 de juego (Play Mode); pasan 14.</a:t>
+            </a:r>
+          </a:p>
+          <a:p>
+            <a:r>
+              <a:t>Respuesta esperada a la pregunta: los 2 tests que fallan encontraron un defecto del juego original, no del porteo. El rayo que detecta el suelo choca con el propio jugador, así que el juego siempre cree que está en el suelo y permite saltar sin límite. Un test en rojo también es evidencia útil. Corregirlo cambia la dificultad del nivel, y esa decisión es de diseño, no técnica.</a:t>
+            </a:r>
+          </a:p>
+          <a:p>
+            <a:r>
+              <a:t>Estado: todo esto está VERIFICADO con logs y XML del 19/10/2026. La instalación en un teléfono real es UNKNOWN.</a:t>
+            </a:r>
+          </a:p>
+        </p:txBody>
+      </p:sp>
+      <p:sp>
+        <p:nvSpPr>
+          <p:cNvPr id="4" name="Slide Number Placeholder 3"/>
+          <p:cNvSpPr>
+            <a:spLocks noGrp="1"/>
+          </p:cNvSpPr>
+          <p:nvPr>
+            <p:ph type="sldNum" idx="5" sz="quarter"/>
+          </p:nvPr>
+        </p:nvSpPr>
+        <p:spPr/>
+      </p:sp>
+    </p:spTree>
+  </p:cSld>
+  <p:clrMapOvr>
+    <a:masterClrMapping/>
+  </p:clrMapOvr>
+</p:notes>
+</file>
+
 <file path=ppt/notesSlides/notesSlide7.xml><?xml version="1.0" encoding="utf-8"?>
 <p:notes xmlns:a="http://schemas.openxmlformats.org/drawingml/2006/main" xmlns:p="http://schemas.openxmlformats.org/presentationml/2006/main" xmlns:r="http://schemas.openxmlformats.org/officeDocument/2006/relationships">
   <p:cSld>
@@ -6945,6 +7267,11 @@
           <a:p>
             <a:r>
               <a:t>Recorrer el gráfico de izquierda a derecha y no detenerse más de 3 minutos.</a:t>
+            </a:r>
+          </a:p>
+          <a:p>
+            <a:r>
+              <a:t>Video de consulta, en español (agregado el 2026-10-19; existencia, título, canal y fecha verificados con YouTube el 2026-10-19; el contenido no se revisó completo): Academia Play, "Historia de los Videojuegos (1972-1983) Parte I" (7 min, 10/07/2019): https://www.youtube.com/watch?v=KRRfb-pSZy8. Según su descripción, recorre Pong, Space Invaders, Pac-Man y Donkey Kong hasta la crisis de 1983: los mismos hitos del gráfico.</a:t>
             </a:r>
           </a:p>
         </p:txBody>
@@ -10338,7 +10665,7 @@
                 </a:solidFill>
                 <a:latin typeface="Calibri"/>
               </a:rPr>
-              <a:t>Unidad IV · Clase 1 · final (dada hasta la slide 15) · 1/63</a:t>
+              <a:t>Unidad IV · Clase 1 · final (dada hasta la slide 15) · 1/65</a:t>
             </a:r>
           </a:p>
         </p:txBody>
@@ -10619,7 +10946,7 @@
                 </a:solidFill>
                 <a:latin typeface="Calibri"/>
               </a:rPr>
-              <a:t>10/63</a:t>
+              <a:t>10/65</a:t>
             </a:r>
           </a:p>
         </p:txBody>
@@ -12650,7 +12977,7 @@
                 </a:solidFill>
                 <a:latin typeface="Calibri"/>
               </a:rPr>
-              <a:t>11/63</a:t>
+              <a:t>11/65</a:t>
             </a:r>
           </a:p>
         </p:txBody>
@@ -13679,7 +14006,7 @@
                 </a:solidFill>
                 <a:latin typeface="Calibri"/>
               </a:rPr>
-              <a:t>12/63</a:t>
+              <a:t>12/65</a:t>
             </a:r>
           </a:p>
         </p:txBody>
@@ -14101,7 +14428,7 @@
                 </a:solidFill>
                 <a:latin typeface="Calibri"/>
               </a:rPr>
-              <a:t>13/63</a:t>
+              <a:t>13/65</a:t>
             </a:r>
           </a:p>
         </p:txBody>
@@ -14943,7 +15270,7 @@
                 </a:solidFill>
                 <a:latin typeface="Calibri"/>
               </a:rPr>
-              <a:t>14/63</a:t>
+              <a:t>14/65</a:t>
             </a:r>
           </a:p>
         </p:txBody>
@@ -15390,7 +15717,7 @@
                 </a:solidFill>
                 <a:latin typeface="Calibri"/>
               </a:rPr>
-              <a:t>15/63</a:t>
+              <a:t>15/65</a:t>
             </a:r>
           </a:p>
         </p:txBody>
@@ -16335,7 +16662,7 @@
                 </a:solidFill>
                 <a:latin typeface="Calibri"/>
               </a:rPr>
-              <a:t>Unidad IV · Clase 2 · final · 16/63</a:t>
+              <a:t>Unidad IV · Clase 2 · final · 16/65</a:t>
             </a:r>
           </a:p>
         </p:txBody>
@@ -16616,7 +16943,7 @@
                 </a:solidFill>
                 <a:latin typeface="Calibri"/>
               </a:rPr>
-              <a:t>17/63</a:t>
+              <a:t>17/65</a:t>
             </a:r>
           </a:p>
         </p:txBody>
@@ -17101,7 +17428,7 @@
                 </a:solidFill>
                 <a:latin typeface="Calibri"/>
               </a:rPr>
-              <a:t>18/63</a:t>
+              <a:t>18/65</a:t>
             </a:r>
           </a:p>
         </p:txBody>
@@ -17612,7 +17939,7 @@
                 </a:solidFill>
                 <a:latin typeface="Calibri"/>
               </a:rPr>
-              <a:t>19/63</a:t>
+              <a:t>19/65</a:t>
             </a:r>
           </a:p>
         </p:txBody>
@@ -18472,7 +18799,7 @@
                 </a:solidFill>
                 <a:latin typeface="Calibri"/>
               </a:rPr>
-              <a:t>2/63</a:t>
+              <a:t>2/65</a:t>
             </a:r>
           </a:p>
         </p:txBody>
@@ -18982,7 +19309,7 @@
                 </a:solidFill>
                 <a:latin typeface="Calibri"/>
               </a:rPr>
-              <a:t>20/63</a:t>
+              <a:t>20/65</a:t>
             </a:r>
           </a:p>
         </p:txBody>
@@ -19983,7 +20310,7 @@
                 </a:solidFill>
                 <a:latin typeface="Calibri"/>
               </a:rPr>
-              <a:t>21/63</a:t>
+              <a:t>21/65</a:t>
             </a:r>
           </a:p>
         </p:txBody>
@@ -20561,7 +20888,7 @@
                 </a:solidFill>
                 <a:latin typeface="Calibri"/>
               </a:rPr>
-              <a:t>22/63</a:t>
+              <a:t>22/65</a:t>
             </a:r>
           </a:p>
         </p:txBody>
@@ -21189,7 +21516,7 @@
                 </a:solidFill>
                 <a:latin typeface="Calibri"/>
               </a:rPr>
-              <a:t>23/63</a:t>
+              <a:t>23/65</a:t>
             </a:r>
           </a:p>
         </p:txBody>
@@ -21915,7 +22242,7 @@
                 </a:solidFill>
                 <a:latin typeface="Calibri"/>
               </a:rPr>
-              <a:t>24/63</a:t>
+              <a:t>24/65</a:t>
             </a:r>
           </a:p>
         </p:txBody>
@@ -22468,7 +22795,7 @@
                 </a:solidFill>
                 <a:latin typeface="Calibri"/>
               </a:rPr>
-              <a:t>25/63</a:t>
+              <a:t>25/65</a:t>
             </a:r>
           </a:p>
         </p:txBody>
@@ -23267,7 +23594,7 @@
                 </a:solidFill>
                 <a:latin typeface="Calibri"/>
               </a:rPr>
-              <a:t>26/63</a:t>
+              <a:t>26/65</a:t>
             </a:r>
           </a:p>
         </p:txBody>
@@ -24482,7 +24809,7 @@
                 </a:solidFill>
                 <a:latin typeface="Calibri"/>
               </a:rPr>
-              <a:t>27/63</a:t>
+              <a:t>27/65</a:t>
             </a:r>
           </a:p>
         </p:txBody>
@@ -25191,7 +25518,7 @@
                 </a:solidFill>
                 <a:latin typeface="Calibri"/>
               </a:rPr>
-              <a:t>28/63</a:t>
+              <a:t>28/65</a:t>
             </a:r>
           </a:p>
         </p:txBody>
@@ -26005,7 +26332,7 @@
                 </a:solidFill>
                 <a:latin typeface="Calibri"/>
               </a:rPr>
-              <a:t>29/63</a:t>
+              <a:t>29/65</a:t>
             </a:r>
           </a:p>
         </p:txBody>
@@ -26490,7 +26817,7 @@
                 </a:solidFill>
                 <a:latin typeface="Calibri"/>
               </a:rPr>
-              <a:t>3/63</a:t>
+              <a:t>3/65</a:t>
             </a:r>
           </a:p>
         </p:txBody>
@@ -27755,7 +28082,7 @@
                 </a:solidFill>
                 <a:latin typeface="Calibri"/>
               </a:rPr>
-              <a:t>30/63</a:t>
+              <a:t>30/65</a:t>
             </a:r>
           </a:p>
         </p:txBody>
@@ -28295,7 +28622,7 @@
                 </a:solidFill>
                 <a:latin typeface="Calibri"/>
               </a:rPr>
-              <a:t>31/63</a:t>
+              <a:t>31/65</a:t>
             </a:r>
           </a:p>
         </p:txBody>
@@ -28706,7 +29033,7 @@
                 </a:solidFill>
                 <a:latin typeface="Calibri"/>
               </a:rPr>
-              <a:t>Unidad IV · Clase 3 · final · 32/63</a:t>
+              <a:t>Unidad IV · Clase 3 · final · 32/65</a:t>
             </a:r>
           </a:p>
         </p:txBody>
@@ -28987,7 +29314,7 @@
                 </a:solidFill>
                 <a:latin typeface="Calibri"/>
               </a:rPr>
-              <a:t>33/63</a:t>
+              <a:t>33/65</a:t>
             </a:r>
           </a:p>
         </p:txBody>
@@ -29472,7 +29799,7 @@
                 </a:solidFill>
                 <a:latin typeface="Calibri"/>
               </a:rPr>
-              <a:t>34/63</a:t>
+              <a:t>34/65</a:t>
             </a:r>
           </a:p>
         </p:txBody>
@@ -29923,7 +30250,7 @@
                 </a:solidFill>
                 <a:latin typeface="Calibri"/>
               </a:rPr>
-              <a:t>35/63</a:t>
+              <a:t>35/65</a:t>
             </a:r>
           </a:p>
         </p:txBody>
@@ -31471,7 +31798,7 @@
                 </a:solidFill>
                 <a:latin typeface="Calibri"/>
               </a:rPr>
-              <a:t>36/63</a:t>
+              <a:t>36/65</a:t>
             </a:r>
           </a:p>
         </p:txBody>
@@ -32049,7 +32376,7 @@
                 </a:solidFill>
                 <a:latin typeface="Calibri"/>
               </a:rPr>
-              <a:t>37/63</a:t>
+              <a:t>37/65</a:t>
             </a:r>
           </a:p>
         </p:txBody>
@@ -32932,7 +33259,7 @@
                 </a:solidFill>
                 <a:latin typeface="Calibri"/>
               </a:rPr>
-              <a:t>38/63</a:t>
+              <a:t>38/65</a:t>
             </a:r>
           </a:p>
         </p:txBody>
@@ -33460,7 +33787,7 @@
                 </a:solidFill>
                 <a:latin typeface="Calibri"/>
               </a:rPr>
-              <a:t>39/63</a:t>
+              <a:t>39/65</a:t>
             </a:r>
           </a:p>
         </p:txBody>
@@ -34214,7 +34541,7 @@
                 </a:solidFill>
                 <a:latin typeface="Calibri"/>
               </a:rPr>
-              <a:t>4/63</a:t>
+              <a:t>4/65</a:t>
             </a:r>
           </a:p>
         </p:txBody>
@@ -34643,7 +34970,7 @@
                 </a:solidFill>
                 <a:latin typeface="Calibri"/>
               </a:rPr>
-              <a:t>40/63</a:t>
+              <a:t>40/65</a:t>
             </a:r>
           </a:p>
         </p:txBody>
@@ -35128,7 +35455,7 @@
                 </a:solidFill>
                 <a:latin typeface="Calibri"/>
               </a:rPr>
-              <a:t>41/63</a:t>
+              <a:t>41/65</a:t>
             </a:r>
           </a:p>
         </p:txBody>
@@ -36200,7 +36527,7 @@
                 </a:solidFill>
                 <a:latin typeface="Calibri"/>
               </a:rPr>
-              <a:t>42/63</a:t>
+              <a:t>42/65</a:t>
             </a:r>
           </a:p>
         </p:txBody>
@@ -37285,7 +37612,7 @@
                 </a:solidFill>
                 <a:latin typeface="Calibri"/>
               </a:rPr>
-              <a:t>43/63</a:t>
+              <a:t>43/65</a:t>
             </a:r>
           </a:p>
         </p:txBody>
@@ -38112,7 +38439,7 @@
                 </a:solidFill>
                 <a:latin typeface="Calibri"/>
               </a:rPr>
-              <a:t>44/63</a:t>
+              <a:t>44/65</a:t>
             </a:r>
           </a:p>
         </p:txBody>
@@ -38597,7 +38924,7 @@
                 </a:solidFill>
                 <a:latin typeface="Calibri"/>
               </a:rPr>
-              <a:t>45/63</a:t>
+              <a:t>45/65</a:t>
             </a:r>
           </a:p>
         </p:txBody>
@@ -39371,7 +39698,7 @@
                 </a:solidFill>
                 <a:latin typeface="Calibri"/>
               </a:rPr>
-              <a:t>46/63</a:t>
+              <a:t>46/65</a:t>
             </a:r>
           </a:p>
         </p:txBody>
@@ -40087,7 +40414,7 @@
                 </a:solidFill>
                 <a:latin typeface="Calibri"/>
               </a:rPr>
-              <a:t>47/63</a:t>
+              <a:t>47/65</a:t>
             </a:r>
           </a:p>
         </p:txBody>
@@ -40597,7 +40924,7 @@
                 </a:solidFill>
                 <a:latin typeface="Calibri"/>
               </a:rPr>
-              <a:t>48/63</a:t>
+              <a:t>48/65</a:t>
             </a:r>
           </a:p>
         </p:txBody>
@@ -40640,7 +40967,7 @@
                 </a:solidFill>
                 <a:latin typeface="Calibri"/>
               </a:rPr>
-              <a:t>FTC, comunicado de prensa del 19/12/2022</a:t>
+              <a:t>FTC, comunicado de prensa del 19/12/2022; ACM (Países Bajos), 14/01/2026</a:t>
             </a:r>
           </a:p>
         </p:txBody>
@@ -40654,6 +40981,170 @@
         <p:spPr>
           <a:xfrm>
             <a:off x="502920" y="5577840"/>
+            <a:ext cx="109728" cy="457200"/>
+          </a:xfrm>
+          <a:prstGeom prst="rect">
+            <a:avLst/>
+          </a:prstGeom>
+          <a:solidFill>
+            <a:srgbClr val="DC2626"/>
+          </a:solidFill>
+          <a:ln>
+            <a:noFill/>
+          </a:ln>
+          <a:effectLst/>
+        </p:spPr>
+        <p:style>
+          <a:lnRef idx="1">
+            <a:schemeClr val="accent1"/>
+          </a:lnRef>
+          <a:fillRef idx="3">
+            <a:schemeClr val="accent1"/>
+          </a:fillRef>
+          <a:effectRef idx="2">
+            <a:schemeClr val="accent1"/>
+          </a:effectRef>
+          <a:fontRef idx="minor">
+            <a:schemeClr val="lt1"/>
+          </a:fontRef>
+        </p:style>
+        <p:txBody>
+          <a:bodyPr rtlCol="0" anchor="ctr"/>
+          <a:lstStyle/>
+          <a:p>
+            <a:pPr algn="ctr"/>
+          </a:p>
+        </p:txBody>
+      </p:sp>
+      <p:sp>
+        <p:nvSpPr>
+          <p:cNvPr id="10" name="Rectangle 9"/>
+          <p:cNvSpPr/>
+          <p:nvPr/>
+        </p:nvSpPr>
+        <p:spPr>
+          <a:xfrm>
+            <a:off x="612648" y="5577840"/>
+            <a:ext cx="11076127" cy="457200"/>
+          </a:xfrm>
+          <a:prstGeom prst="rect">
+            <a:avLst/>
+          </a:prstGeom>
+          <a:solidFill>
+            <a:srgbClr val="F3F4F6"/>
+          </a:solidFill>
+          <a:ln>
+            <a:noFill/>
+          </a:ln>
+          <a:effectLst/>
+        </p:spPr>
+        <p:style>
+          <a:lnRef idx="1">
+            <a:schemeClr val="accent1"/>
+          </a:lnRef>
+          <a:fillRef idx="3">
+            <a:schemeClr val="accent1"/>
+          </a:fillRef>
+          <a:effectRef idx="2">
+            <a:schemeClr val="accent1"/>
+          </a:effectRef>
+          <a:fontRef idx="minor">
+            <a:schemeClr val="lt1"/>
+          </a:fontRef>
+        </p:style>
+        <p:txBody>
+          <a:bodyPr rtlCol="0" anchor="ctr" wrap="square" lIns="137160"/>
+          <a:lstStyle/>
+          <a:p>
+            <a:pPr algn="l"/>
+            <a:r>
+              <a:rPr sz="1300" b="1" i="0">
+                <a:solidFill>
+                  <a:srgbClr val="DC2626"/>
+                </a:solidFill>
+                <a:latin typeface="Calibri"/>
+              </a:rPr>
+              <a:t>VIDEO  </a:t>
+            </a:r>
+            <a:r>
+              <a:rPr sz="1400" b="1" i="0" u="sng">
+                <a:solidFill>
+                  <a:srgbClr val="DC2626"/>
+                </a:solidFill>
+                <a:latin typeface="Calibri"/>
+                <a:hlinkClick r:id="rId2"/>
+              </a:rPr>
+              <a:t>La Tercera</a:t>
+            </a:r>
+            <a:r>
+              <a:rPr sz="1400" b="0" i="0">
+                <a:solidFill>
+                  <a:srgbClr val="1F2937"/>
+                </a:solidFill>
+                <a:latin typeface="Calibri"/>
+              </a:rPr>
+              <a:t> · </a:t>
+            </a:r>
+            <a:r>
+              <a:rPr sz="1400" b="1" i="0" u="sng">
+                <a:solidFill>
+                  <a:srgbClr val="DC2626"/>
+                </a:solidFill>
+                <a:latin typeface="Calibri"/>
+                <a:hlinkClick r:id="rId3"/>
+              </a:rPr>
+              <a:t>El Deber</a:t>
+            </a:r>
+            <a:r>
+              <a:rPr sz="1400" b="0" i="0">
+                <a:solidFill>
+                  <a:srgbClr val="1F2937"/>
+                </a:solidFill>
+                <a:latin typeface="Calibri"/>
+              </a:rPr>
+              <a:t> · </a:t>
+            </a:r>
+            <a:r>
+              <a:rPr sz="1400" b="1" i="0" u="sng">
+                <a:solidFill>
+                  <a:srgbClr val="DC2626"/>
+                </a:solidFill>
+                <a:latin typeface="Calibri"/>
+                <a:hlinkClick r:id="rId4"/>
+              </a:rPr>
+              <a:t>El Sol de México</a:t>
+            </a:r>
+            <a:r>
+              <a:rPr sz="1400" b="0" i="0">
+                <a:solidFill>
+                  <a:srgbClr val="1F2937"/>
+                </a:solidFill>
+                <a:latin typeface="Calibri"/>
+              </a:rPr>
+              <a:t> · </a:t>
+            </a:r>
+            <a:r>
+              <a:rPr sz="1400" b="1" i="0" u="sng">
+                <a:solidFill>
+                  <a:srgbClr val="DC2626"/>
+                </a:solidFill>
+                <a:latin typeface="Calibri"/>
+                <a:hlinkClick r:id="rId5"/>
+              </a:rPr>
+              <a:t>DW Español (12 min)</a:t>
+            </a:r>
+          </a:p>
+        </p:txBody>
+      </p:sp>
+      <p:sp>
+        <p:nvSpPr>
+          <p:cNvPr id="11" name="Rectangle 10"/>
+          <p:cNvSpPr/>
+          <p:nvPr/>
+        </p:nvSpPr>
+        <p:spPr>
+          <a:xfrm>
+            <a:off x="502920" y="5029200"/>
             <a:ext cx="109728" cy="457200"/>
           </a:xfrm>
           <a:prstGeom prst="rect">
@@ -40691,13 +41182,13 @@
       </p:sp>
       <p:sp>
         <p:nvSpPr>
-          <p:cNvPr id="10" name="Rectangle 9"/>
+          <p:cNvPr id="12" name="Rectangle 11"/>
           <p:cNvSpPr/>
           <p:nvPr/>
         </p:nvSpPr>
         <p:spPr>
           <a:xfrm>
-            <a:off x="612648" y="5577840"/>
+            <a:off x="612648" y="5029200"/>
             <a:ext cx="11076127" cy="457200"/>
           </a:xfrm>
           <a:prstGeom prst="rect">
@@ -40753,14 +41244,14 @@
       </p:sp>
       <p:sp>
         <p:nvSpPr>
-          <p:cNvPr id="11" name="TextBox 10"/>
+          <p:cNvPr id="13" name="TextBox 12"/>
           <p:cNvSpPr txBox="1"/>
           <p:nvPr/>
         </p:nvSpPr>
         <p:spPr>
           <a:xfrm>
             <a:off x="502920" y="1234440"/>
-            <a:ext cx="11185855" cy="4206240"/>
+            <a:ext cx="11185855" cy="3657600"/>
           </a:xfrm>
           <a:prstGeom prst="rect">
             <a:avLst/>
@@ -40845,6 +41336,31 @@
                 <a:latin typeface="Calibri"/>
               </a:rPr>
               <a:t>Botones confusos al comprar</a:t>
+            </a:r>
+          </a:p>
+          <a:p>
+            <a:pPr>
+              <a:spcAft>
+                <a:spcPts val="800"/>
+              </a:spcAft>
+            </a:pPr>
+            <a:r>
+              <a:rPr sz="1600" b="1" i="0">
+                <a:solidFill>
+                  <a:srgbClr val="0D9488"/>
+                </a:solidFill>
+                <a:latin typeface="Calibri"/>
+              </a:rPr>
+              <a:t>■  </a:t>
+            </a:r>
+            <a:r>
+              <a:rPr sz="2200" b="0" i="0">
+                <a:solidFill>
+                  <a:srgbClr val="1F2937"/>
+                </a:solidFill>
+                <a:latin typeface="Calibri"/>
+              </a:rPr>
+              <a:t>Países Bajos: € 1,125 M (2024)</a:t>
             </a:r>
           </a:p>
         </p:txBody>
@@ -41125,7 +41641,7 @@
                 </a:solidFill>
                 <a:latin typeface="Calibri"/>
               </a:rPr>
-              <a:t>49/63</a:t>
+              <a:t>49/65</a:t>
             </a:r>
           </a:p>
         </p:txBody>
@@ -41816,7 +42332,7 @@
                 </a:solidFill>
                 <a:latin typeface="Calibri"/>
               </a:rPr>
-              <a:t>5/63</a:t>
+              <a:t>5/65</a:t>
             </a:r>
           </a:p>
         </p:txBody>
@@ -42613,7 +43129,7 @@
                 </a:solidFill>
                 <a:latin typeface="Calibri"/>
               </a:rPr>
-              <a:t>50/63</a:t>
+              <a:t>50/65</a:t>
             </a:r>
           </a:p>
         </p:txBody>
@@ -43166,7 +43682,7 @@
                 </a:solidFill>
                 <a:latin typeface="Calibri"/>
               </a:rPr>
-              <a:t>51/63</a:t>
+              <a:t>51/65</a:t>
             </a:r>
           </a:p>
         </p:txBody>
@@ -43719,7 +44235,7 @@
                 </a:solidFill>
                 <a:latin typeface="Calibri"/>
               </a:rPr>
-              <a:t>52/63</a:t>
+              <a:t>52/65</a:t>
             </a:r>
           </a:p>
         </p:txBody>
@@ -44316,7 +44832,7 @@
                 </a:solidFill>
                 <a:latin typeface="Calibri"/>
               </a:rPr>
-              <a:t>53/63</a:t>
+              <a:t>53/65</a:t>
             </a:r>
           </a:p>
         </p:txBody>
@@ -44930,7 +45446,7 @@
                 </a:solidFill>
                 <a:latin typeface="Calibri"/>
               </a:rPr>
-              <a:t>54/63</a:t>
+              <a:t>54/65</a:t>
             </a:r>
           </a:p>
         </p:txBody>
@@ -45340,7 +45856,7 @@
                 </a:solidFill>
                 <a:latin typeface="Calibri"/>
               </a:rPr>
-              <a:t>Unidad IV · Anexo de consulta · 55/63</a:t>
+              <a:t>Unidad IV · Anexo de consulta · 55/65</a:t>
             </a:r>
           </a:p>
         </p:txBody>
@@ -45621,7 +46137,7 @@
                 </a:solidFill>
                 <a:latin typeface="Calibri"/>
               </a:rPr>
-              <a:t>56/63</a:t>
+              <a:t>56/65</a:t>
             </a:r>
           </a:p>
         </p:txBody>
@@ -46132,7 +46648,7 @@
                 </a:solidFill>
                 <a:latin typeface="Calibri"/>
               </a:rPr>
-              <a:t>57/63</a:t>
+              <a:t>57/65</a:t>
             </a:r>
           </a:p>
         </p:txBody>
@@ -47040,7 +47556,7 @@
                 </a:solidFill>
                 <a:latin typeface="Calibri"/>
               </a:rPr>
-              <a:t>58/63</a:t>
+              <a:t>58/65</a:t>
             </a:r>
           </a:p>
         </p:txBody>
@@ -47551,7 +48067,7 @@
                 </a:solidFill>
                 <a:latin typeface="Calibri"/>
               </a:rPr>
-              <a:t>59/63</a:t>
+              <a:t>59/65</a:t>
             </a:r>
           </a:p>
         </p:txBody>
@@ -48091,7 +48607,7 @@
                 </a:solidFill>
                 <a:latin typeface="Calibri"/>
               </a:rPr>
-              <a:t>6/63</a:t>
+              <a:t>6/65</a:t>
             </a:r>
           </a:p>
         </p:txBody>
@@ -48147,8 +48663,143 @@
         </p:nvSpPr>
         <p:spPr>
           <a:xfrm>
+            <a:off x="502920" y="5577840"/>
+            <a:ext cx="109728" cy="457200"/>
+          </a:xfrm>
+          <a:prstGeom prst="rect">
+            <a:avLst/>
+          </a:prstGeom>
+          <a:solidFill>
+            <a:srgbClr val="DC2626"/>
+          </a:solidFill>
+          <a:ln>
+            <a:noFill/>
+          </a:ln>
+          <a:effectLst/>
+        </p:spPr>
+        <p:style>
+          <a:lnRef idx="1">
+            <a:schemeClr val="accent1"/>
+          </a:lnRef>
+          <a:fillRef idx="3">
+            <a:schemeClr val="accent1"/>
+          </a:fillRef>
+          <a:effectRef idx="2">
+            <a:schemeClr val="accent1"/>
+          </a:effectRef>
+          <a:fontRef idx="minor">
+            <a:schemeClr val="lt1"/>
+          </a:fontRef>
+        </p:style>
+        <p:txBody>
+          <a:bodyPr rtlCol="0" anchor="ctr"/>
+          <a:lstStyle/>
+          <a:p>
+            <a:pPr algn="ctr"/>
+          </a:p>
+        </p:txBody>
+      </p:sp>
+      <p:sp>
+        <p:nvSpPr>
+          <p:cNvPr id="10" name="Rectangle 9"/>
+          <p:cNvSpPr/>
+          <p:nvPr/>
+        </p:nvSpPr>
+        <p:spPr>
+          <a:xfrm>
+            <a:off x="612648" y="5577840"/>
+            <a:ext cx="11076127" cy="457200"/>
+          </a:xfrm>
+          <a:prstGeom prst="rect">
+            <a:avLst/>
+          </a:prstGeom>
+          <a:solidFill>
+            <a:srgbClr val="F3F4F6"/>
+          </a:solidFill>
+          <a:ln>
+            <a:noFill/>
+          </a:ln>
+          <a:effectLst/>
+        </p:spPr>
+        <p:style>
+          <a:lnRef idx="1">
+            <a:schemeClr val="accent1"/>
+          </a:lnRef>
+          <a:fillRef idx="3">
+            <a:schemeClr val="accent1"/>
+          </a:fillRef>
+          <a:effectRef idx="2">
+            <a:schemeClr val="accent1"/>
+          </a:effectRef>
+          <a:fontRef idx="minor">
+            <a:schemeClr val="lt1"/>
+          </a:fontRef>
+        </p:style>
+        <p:txBody>
+          <a:bodyPr rtlCol="0" anchor="ctr" wrap="square" lIns="137160"/>
+          <a:lstStyle/>
+          <a:p>
+            <a:pPr algn="l"/>
+            <a:r>
+              <a:rPr sz="1300" b="1" i="0">
+                <a:solidFill>
+                  <a:srgbClr val="DC2626"/>
+                </a:solidFill>
+                <a:latin typeface="Calibri"/>
+              </a:rPr>
+              <a:t>VIDEO  </a:t>
+            </a:r>
+            <a:r>
+              <a:rPr sz="1400" b="0" i="0">
+                <a:solidFill>
+                  <a:srgbClr val="1F2937"/>
+                </a:solidFill>
+                <a:latin typeface="Calibri"/>
+              </a:rPr>
+              <a:t>Consulta: </a:t>
+            </a:r>
+            <a:r>
+              <a:rPr sz="1400" b="1" i="0" u="sng">
+                <a:solidFill>
+                  <a:srgbClr val="DC2626"/>
+                </a:solidFill>
+                <a:latin typeface="Calibri"/>
+                <a:hlinkClick r:id="rId2"/>
+              </a:rPr>
+              <a:t>Juegos de celular, historia (21 min)</a:t>
+            </a:r>
+            <a:r>
+              <a:rPr sz="1400" b="0" i="0">
+                <a:solidFill>
+                  <a:srgbClr val="1F2937"/>
+                </a:solidFill>
+                <a:latin typeface="Calibri"/>
+              </a:rPr>
+              <a:t> · </a:t>
+            </a:r>
+            <a:r>
+              <a:rPr sz="1400" b="1" i="0" u="sng">
+                <a:solidFill>
+                  <a:srgbClr val="DC2626"/>
+                </a:solidFill>
+                <a:latin typeface="Calibri"/>
+                <a:hlinkClick r:id="rId3"/>
+              </a:rPr>
+              <a:t>Antes de las App Stores (9 min)</a:t>
+            </a:r>
+          </a:p>
+        </p:txBody>
+      </p:sp>
+      <p:sp>
+        <p:nvSpPr>
+          <p:cNvPr id="11" name="Rectangle 10"/>
+          <p:cNvSpPr/>
+          <p:nvPr/>
+        </p:nvSpPr>
+        <p:spPr>
+          <a:xfrm>
             <a:off x="7071055" y="1234440"/>
-            <a:ext cx="12700" cy="4069080"/>
+            <a:ext cx="12700" cy="3520440"/>
           </a:xfrm>
           <a:prstGeom prst="rect">
             <a:avLst/>
@@ -48185,13 +48836,13 @@
       </p:sp>
       <p:sp>
         <p:nvSpPr>
-          <p:cNvPr id="10" name="TextBox 9"/>
+          <p:cNvPr id="12" name="TextBox 11"/>
           <p:cNvSpPr txBox="1"/>
           <p:nvPr/>
         </p:nvSpPr>
         <p:spPr>
           <a:xfrm>
-            <a:off x="6705295" y="5349240"/>
+            <a:off x="6705295" y="4800600"/>
             <a:ext cx="731520" cy="274320"/>
           </a:xfrm>
           <a:prstGeom prst="rect">
@@ -48220,14 +48871,14 @@
       </p:sp>
       <p:sp>
         <p:nvSpPr>
-          <p:cNvPr id="11" name="Rectangle 10"/>
+          <p:cNvPr id="13" name="Rectangle 12"/>
           <p:cNvSpPr/>
           <p:nvPr/>
         </p:nvSpPr>
         <p:spPr>
           <a:xfrm>
             <a:off x="7879319" y="1234440"/>
-            <a:ext cx="12700" cy="4069080"/>
+            <a:ext cx="12700" cy="3520440"/>
           </a:xfrm>
           <a:prstGeom prst="rect">
             <a:avLst/>
@@ -48264,13 +48915,13 @@
       </p:sp>
       <p:sp>
         <p:nvSpPr>
-          <p:cNvPr id="12" name="TextBox 11"/>
+          <p:cNvPr id="14" name="TextBox 13"/>
           <p:cNvSpPr txBox="1"/>
           <p:nvPr/>
         </p:nvSpPr>
         <p:spPr>
           <a:xfrm>
-            <a:off x="7513559" y="5349240"/>
+            <a:off x="7513559" y="4800600"/>
             <a:ext cx="731520" cy="274320"/>
           </a:xfrm>
           <a:prstGeom prst="rect">
@@ -48299,14 +48950,14 @@
       </p:sp>
       <p:sp>
         <p:nvSpPr>
-          <p:cNvPr id="13" name="Rectangle 12"/>
+          <p:cNvPr id="15" name="Rectangle 14"/>
           <p:cNvSpPr/>
           <p:nvPr/>
         </p:nvSpPr>
         <p:spPr>
           <a:xfrm>
             <a:off x="8687583" y="1234440"/>
-            <a:ext cx="12700" cy="4069080"/>
+            <a:ext cx="12700" cy="3520440"/>
           </a:xfrm>
           <a:prstGeom prst="rect">
             <a:avLst/>
@@ -48343,13 +48994,13 @@
       </p:sp>
       <p:sp>
         <p:nvSpPr>
-          <p:cNvPr id="14" name="TextBox 13"/>
+          <p:cNvPr id="16" name="TextBox 15"/>
           <p:cNvSpPr txBox="1"/>
           <p:nvPr/>
         </p:nvSpPr>
         <p:spPr>
           <a:xfrm>
-            <a:off x="8321823" y="5349240"/>
+            <a:off x="8321823" y="4800600"/>
             <a:ext cx="731520" cy="274320"/>
           </a:xfrm>
           <a:prstGeom prst="rect">
@@ -48378,14 +49029,14 @@
       </p:sp>
       <p:sp>
         <p:nvSpPr>
-          <p:cNvPr id="15" name="Rectangle 14"/>
+          <p:cNvPr id="17" name="Rectangle 16"/>
           <p:cNvSpPr/>
           <p:nvPr/>
         </p:nvSpPr>
         <p:spPr>
           <a:xfrm>
             <a:off x="9495847" y="1234440"/>
-            <a:ext cx="12700" cy="4069080"/>
+            <a:ext cx="12700" cy="3520440"/>
           </a:xfrm>
           <a:prstGeom prst="rect">
             <a:avLst/>
@@ -48422,13 +49073,13 @@
       </p:sp>
       <p:sp>
         <p:nvSpPr>
-          <p:cNvPr id="16" name="TextBox 15"/>
+          <p:cNvPr id="18" name="TextBox 17"/>
           <p:cNvSpPr txBox="1"/>
           <p:nvPr/>
         </p:nvSpPr>
         <p:spPr>
           <a:xfrm>
-            <a:off x="9130087" y="5349240"/>
+            <a:off x="9130087" y="4800600"/>
             <a:ext cx="731520" cy="274320"/>
           </a:xfrm>
           <a:prstGeom prst="rect">
@@ -48457,14 +49108,14 @@
       </p:sp>
       <p:sp>
         <p:nvSpPr>
-          <p:cNvPr id="17" name="Rectangle 16"/>
+          <p:cNvPr id="19" name="Rectangle 18"/>
           <p:cNvSpPr/>
           <p:nvPr/>
         </p:nvSpPr>
         <p:spPr>
           <a:xfrm>
             <a:off x="10304112" y="1234440"/>
-            <a:ext cx="12700" cy="4069080"/>
+            <a:ext cx="12700" cy="3520440"/>
           </a:xfrm>
           <a:prstGeom prst="rect">
             <a:avLst/>
@@ -48501,13 +49152,13 @@
       </p:sp>
       <p:sp>
         <p:nvSpPr>
-          <p:cNvPr id="18" name="TextBox 17"/>
+          <p:cNvPr id="20" name="TextBox 19"/>
           <p:cNvSpPr txBox="1"/>
           <p:nvPr/>
         </p:nvSpPr>
         <p:spPr>
           <a:xfrm>
-            <a:off x="9938352" y="5349240"/>
+            <a:off x="9938352" y="4800600"/>
             <a:ext cx="731520" cy="274320"/>
           </a:xfrm>
           <a:prstGeom prst="rect">
@@ -48536,14 +49187,14 @@
       </p:sp>
       <p:sp>
         <p:nvSpPr>
-          <p:cNvPr id="19" name="Rectangle 18"/>
+          <p:cNvPr id="21" name="Rectangle 20"/>
           <p:cNvSpPr/>
           <p:nvPr/>
         </p:nvSpPr>
         <p:spPr>
           <a:xfrm>
             <a:off x="11112376" y="1234440"/>
-            <a:ext cx="12700" cy="4069080"/>
+            <a:ext cx="12700" cy="3520440"/>
           </a:xfrm>
           <a:prstGeom prst="rect">
             <a:avLst/>
@@ -48580,13 +49231,13 @@
       </p:sp>
       <p:sp>
         <p:nvSpPr>
-          <p:cNvPr id="20" name="TextBox 19"/>
+          <p:cNvPr id="22" name="TextBox 21"/>
           <p:cNvSpPr txBox="1"/>
           <p:nvPr/>
         </p:nvSpPr>
         <p:spPr>
           <a:xfrm>
-            <a:off x="10746616" y="5349240"/>
+            <a:off x="10746616" y="4800600"/>
             <a:ext cx="731520" cy="274320"/>
           </a:xfrm>
           <a:prstGeom prst="rect">
@@ -48615,14 +49266,14 @@
       </p:sp>
       <p:sp>
         <p:nvSpPr>
-          <p:cNvPr id="21" name="TextBox 20"/>
+          <p:cNvPr id="23" name="TextBox 22"/>
           <p:cNvSpPr txBox="1"/>
           <p:nvPr/>
         </p:nvSpPr>
         <p:spPr>
           <a:xfrm>
             <a:off x="4922215" y="1272540"/>
-            <a:ext cx="2011680" cy="505097"/>
+            <a:ext cx="2011680" cy="426720"/>
           </a:xfrm>
           <a:prstGeom prst="rect">
             <a:avLst/>
@@ -48650,14 +49301,14 @@
       </p:sp>
       <p:sp>
         <p:nvSpPr>
-          <p:cNvPr id="22" name="Rounded Rectangle 21"/>
+          <p:cNvPr id="24" name="Rounded Rectangle 23"/>
           <p:cNvSpPr/>
           <p:nvPr/>
         </p:nvSpPr>
         <p:spPr>
           <a:xfrm>
             <a:off x="7232707" y="1272540"/>
-            <a:ext cx="4364628" cy="505097"/>
+            <a:ext cx="4364628" cy="426720"/>
           </a:xfrm>
           <a:prstGeom prst="roundRect">
             <a:avLst>
@@ -48705,14 +49356,14 @@
       </p:sp>
       <p:sp>
         <p:nvSpPr>
-          <p:cNvPr id="23" name="TextBox 22"/>
+          <p:cNvPr id="25" name="TextBox 24"/>
           <p:cNvSpPr txBox="1"/>
           <p:nvPr/>
         </p:nvSpPr>
         <p:spPr>
           <a:xfrm>
-            <a:off x="4922215" y="1853837"/>
-            <a:ext cx="2011680" cy="505097"/>
+            <a:off x="4922215" y="1775460"/>
+            <a:ext cx="2011680" cy="426720"/>
           </a:xfrm>
           <a:prstGeom prst="rect">
             <a:avLst/>
@@ -48740,14 +49391,14 @@
       </p:sp>
       <p:sp>
         <p:nvSpPr>
-          <p:cNvPr id="24" name="Rounded Rectangle 23"/>
+          <p:cNvPr id="26" name="Rounded Rectangle 25"/>
           <p:cNvSpPr/>
           <p:nvPr/>
         </p:nvSpPr>
         <p:spPr>
           <a:xfrm>
-            <a:off x="7636840" y="1853837"/>
-            <a:ext cx="3960495" cy="505097"/>
+            <a:off x="7636840" y="1775460"/>
+            <a:ext cx="3960495" cy="426720"/>
           </a:xfrm>
           <a:prstGeom prst="roundRect">
             <a:avLst>
@@ -48795,14 +49446,14 @@
       </p:sp>
       <p:sp>
         <p:nvSpPr>
-          <p:cNvPr id="25" name="TextBox 24"/>
+          <p:cNvPr id="27" name="TextBox 26"/>
           <p:cNvSpPr txBox="1"/>
           <p:nvPr/>
         </p:nvSpPr>
         <p:spPr>
           <a:xfrm>
-            <a:off x="4922215" y="2435134"/>
-            <a:ext cx="2011680" cy="505097"/>
+            <a:off x="4922215" y="2278380"/>
+            <a:ext cx="2011680" cy="426720"/>
           </a:xfrm>
           <a:prstGeom prst="rect">
             <a:avLst/>
@@ -48830,14 +49481,14 @@
       </p:sp>
       <p:sp>
         <p:nvSpPr>
-          <p:cNvPr id="26" name="Rounded Rectangle 25"/>
+          <p:cNvPr id="28" name="Rounded Rectangle 27"/>
           <p:cNvSpPr/>
           <p:nvPr/>
         </p:nvSpPr>
         <p:spPr>
           <a:xfrm>
-            <a:off x="7960145" y="2435134"/>
-            <a:ext cx="3637190" cy="505097"/>
+            <a:off x="7960145" y="2278380"/>
+            <a:ext cx="3637190" cy="426720"/>
           </a:xfrm>
           <a:prstGeom prst="roundRect">
             <a:avLst>
@@ -48885,14 +49536,14 @@
       </p:sp>
       <p:sp>
         <p:nvSpPr>
-          <p:cNvPr id="27" name="TextBox 26"/>
+          <p:cNvPr id="29" name="TextBox 28"/>
           <p:cNvSpPr txBox="1"/>
           <p:nvPr/>
         </p:nvSpPr>
         <p:spPr>
           <a:xfrm>
-            <a:off x="4922215" y="3016431"/>
-            <a:ext cx="2011680" cy="505097"/>
+            <a:off x="4922215" y="2781300"/>
+            <a:ext cx="2011680" cy="426720"/>
           </a:xfrm>
           <a:prstGeom prst="rect">
             <a:avLst/>
@@ -48920,14 +49571,14 @@
       </p:sp>
       <p:sp>
         <p:nvSpPr>
-          <p:cNvPr id="28" name="Rounded Rectangle 27"/>
+          <p:cNvPr id="30" name="Rounded Rectangle 29"/>
           <p:cNvSpPr/>
           <p:nvPr/>
         </p:nvSpPr>
         <p:spPr>
           <a:xfrm>
-            <a:off x="8606757" y="3016431"/>
-            <a:ext cx="2990578" cy="505097"/>
+            <a:off x="8606757" y="2781300"/>
+            <a:ext cx="2990578" cy="426720"/>
           </a:xfrm>
           <a:prstGeom prst="roundRect">
             <a:avLst>
@@ -48975,14 +49626,14 @@
       </p:sp>
       <p:sp>
         <p:nvSpPr>
-          <p:cNvPr id="29" name="TextBox 28"/>
+          <p:cNvPr id="31" name="TextBox 30"/>
           <p:cNvSpPr txBox="1"/>
           <p:nvPr/>
         </p:nvSpPr>
         <p:spPr>
           <a:xfrm>
-            <a:off x="4922215" y="3597728"/>
-            <a:ext cx="2011680" cy="505097"/>
+            <a:off x="4922215" y="3284220"/>
+            <a:ext cx="2011680" cy="426720"/>
           </a:xfrm>
           <a:prstGeom prst="rect">
             <a:avLst/>
@@ -49010,14 +49661,14 @@
       </p:sp>
       <p:sp>
         <p:nvSpPr>
-          <p:cNvPr id="30" name="Rounded Rectangle 29"/>
+          <p:cNvPr id="32" name="Rounded Rectangle 31"/>
           <p:cNvSpPr/>
           <p:nvPr/>
         </p:nvSpPr>
         <p:spPr>
           <a:xfrm>
-            <a:off x="10142459" y="3597728"/>
-            <a:ext cx="1454876" cy="505097"/>
+            <a:off x="10142459" y="3284220"/>
+            <a:ext cx="1454876" cy="426720"/>
           </a:xfrm>
           <a:prstGeom prst="roundRect">
             <a:avLst>
@@ -49065,14 +49716,14 @@
       </p:sp>
       <p:sp>
         <p:nvSpPr>
-          <p:cNvPr id="31" name="TextBox 30"/>
+          <p:cNvPr id="33" name="TextBox 32"/>
           <p:cNvSpPr txBox="1"/>
           <p:nvPr/>
         </p:nvSpPr>
         <p:spPr>
           <a:xfrm>
-            <a:off x="4922215" y="4179025"/>
-            <a:ext cx="2011680" cy="505097"/>
+            <a:off x="4922215" y="3787140"/>
+            <a:ext cx="2011680" cy="426720"/>
           </a:xfrm>
           <a:prstGeom prst="rect">
             <a:avLst/>
@@ -49100,14 +49751,14 @@
       </p:sp>
       <p:sp>
         <p:nvSpPr>
-          <p:cNvPr id="32" name="Rounded Rectangle 31"/>
+          <p:cNvPr id="34" name="Rounded Rectangle 33"/>
           <p:cNvSpPr/>
           <p:nvPr/>
         </p:nvSpPr>
         <p:spPr>
           <a:xfrm>
-            <a:off x="10789070" y="4179025"/>
-            <a:ext cx="808265" cy="505097"/>
+            <a:off x="10789070" y="3787140"/>
+            <a:ext cx="808265" cy="426720"/>
           </a:xfrm>
           <a:prstGeom prst="roundRect">
             <a:avLst>
@@ -49155,14 +49806,14 @@
       </p:sp>
       <p:sp>
         <p:nvSpPr>
-          <p:cNvPr id="33" name="TextBox 32"/>
+          <p:cNvPr id="35" name="TextBox 34"/>
           <p:cNvSpPr txBox="1"/>
           <p:nvPr/>
         </p:nvSpPr>
         <p:spPr>
           <a:xfrm>
-            <a:off x="4922215" y="4760322"/>
-            <a:ext cx="2011680" cy="505097"/>
+            <a:off x="4922215" y="4290060"/>
+            <a:ext cx="2011680" cy="426720"/>
           </a:xfrm>
           <a:prstGeom prst="rect">
             <a:avLst/>
@@ -49190,14 +49841,14 @@
       </p:sp>
       <p:sp>
         <p:nvSpPr>
-          <p:cNvPr id="34" name="Rounded Rectangle 33"/>
+          <p:cNvPr id="36" name="Rounded Rectangle 35"/>
           <p:cNvSpPr/>
           <p:nvPr/>
         </p:nvSpPr>
         <p:spPr>
           <a:xfrm>
-            <a:off x="11112376" y="4760322"/>
-            <a:ext cx="484959" cy="505097"/>
+            <a:off x="11112376" y="4290060"/>
+            <a:ext cx="484959" cy="426720"/>
           </a:xfrm>
           <a:prstGeom prst="roundRect">
             <a:avLst>
@@ -49236,14 +49887,14 @@
       </p:sp>
       <p:sp>
         <p:nvSpPr>
-          <p:cNvPr id="35" name="TextBox 34"/>
+          <p:cNvPr id="37" name="TextBox 36"/>
           <p:cNvSpPr txBox="1"/>
           <p:nvPr/>
         </p:nvSpPr>
         <p:spPr>
           <a:xfrm>
-            <a:off x="10426576" y="4760322"/>
-            <a:ext cx="621792" cy="505097"/>
+            <a:off x="10426576" y="4290060"/>
+            <a:ext cx="621792" cy="426720"/>
           </a:xfrm>
           <a:prstGeom prst="rect">
             <a:avLst/>
@@ -49271,13 +49922,13 @@
       </p:sp>
       <p:sp>
         <p:nvSpPr>
-          <p:cNvPr id="36" name="TextBox 35"/>
+          <p:cNvPr id="38" name="TextBox 37"/>
           <p:cNvSpPr txBox="1"/>
           <p:nvPr/>
         </p:nvSpPr>
         <p:spPr>
           <a:xfrm>
-            <a:off x="4922215" y="5669280"/>
+            <a:off x="4922215" y="5120640"/>
             <a:ext cx="6766560" cy="320040"/>
           </a:xfrm>
           <a:prstGeom prst="rect">
@@ -49306,14 +49957,14 @@
       </p:sp>
       <p:sp>
         <p:nvSpPr>
-          <p:cNvPr id="37" name="TextBox 36"/>
+          <p:cNvPr id="39" name="TextBox 38"/>
           <p:cNvSpPr txBox="1"/>
           <p:nvPr/>
         </p:nvSpPr>
         <p:spPr>
           <a:xfrm>
             <a:off x="502920" y="1234440"/>
-            <a:ext cx="4144975" cy="4754880"/>
+            <a:ext cx="4144975" cy="4206240"/>
           </a:xfrm>
           <a:prstGeom prst="rect">
             <a:avLst/>
@@ -49728,7 +50379,7 @@
                 </a:solidFill>
                 <a:latin typeface="Calibri"/>
               </a:rPr>
-              <a:t>60/63</a:t>
+              <a:t>60/65</a:t>
             </a:r>
           </a:p>
         </p:txBody>
@@ -50239,7 +50890,7 @@
                 </a:solidFill>
                 <a:latin typeface="Calibri"/>
               </a:rPr>
-              <a:t>61/63</a:t>
+              <a:t>61/65</a:t>
             </a:r>
           </a:p>
         </p:txBody>
@@ -50750,7 +51401,7 @@
                 </a:solidFill>
                 <a:latin typeface="Calibri"/>
               </a:rPr>
-              <a:t>62/63</a:t>
+              <a:t>62/65</a:t>
             </a:r>
           </a:p>
         </p:txBody>
@@ -50798,23 +51449,158 @@
           </a:p>
         </p:txBody>
       </p:sp>
+      <p:sp>
+        <p:nvSpPr>
+          <p:cNvPr id="9" name="Rectangle 8"/>
+          <p:cNvSpPr/>
+          <p:nvPr/>
+        </p:nvSpPr>
+        <p:spPr>
+          <a:xfrm>
+            <a:off x="502920" y="5577840"/>
+            <a:ext cx="109728" cy="457200"/>
+          </a:xfrm>
+          <a:prstGeom prst="rect">
+            <a:avLst/>
+          </a:prstGeom>
+          <a:solidFill>
+            <a:srgbClr val="DC2626"/>
+          </a:solidFill>
+          <a:ln>
+            <a:noFill/>
+          </a:ln>
+          <a:effectLst/>
+        </p:spPr>
+        <p:style>
+          <a:lnRef idx="1">
+            <a:schemeClr val="accent1"/>
+          </a:lnRef>
+          <a:fillRef idx="3">
+            <a:schemeClr val="accent1"/>
+          </a:fillRef>
+          <a:effectRef idx="2">
+            <a:schemeClr val="accent1"/>
+          </a:effectRef>
+          <a:fontRef idx="minor">
+            <a:schemeClr val="lt1"/>
+          </a:fontRef>
+        </p:style>
+        <p:txBody>
+          <a:bodyPr rtlCol="0" anchor="ctr"/>
+          <a:lstStyle/>
+          <a:p>
+            <a:pPr algn="ctr"/>
+          </a:p>
+        </p:txBody>
+      </p:sp>
+      <p:sp>
+        <p:nvSpPr>
+          <p:cNvPr id="10" name="Rectangle 9"/>
+          <p:cNvSpPr/>
+          <p:nvPr/>
+        </p:nvSpPr>
+        <p:spPr>
+          <a:xfrm>
+            <a:off x="612648" y="5577840"/>
+            <a:ext cx="11076127" cy="457200"/>
+          </a:xfrm>
+          <a:prstGeom prst="rect">
+            <a:avLst/>
+          </a:prstGeom>
+          <a:solidFill>
+            <a:srgbClr val="F3F4F6"/>
+          </a:solidFill>
+          <a:ln>
+            <a:noFill/>
+          </a:ln>
+          <a:effectLst/>
+        </p:spPr>
+        <p:style>
+          <a:lnRef idx="1">
+            <a:schemeClr val="accent1"/>
+          </a:lnRef>
+          <a:fillRef idx="3">
+            <a:schemeClr val="accent1"/>
+          </a:fillRef>
+          <a:effectRef idx="2">
+            <a:schemeClr val="accent1"/>
+          </a:effectRef>
+          <a:fontRef idx="minor">
+            <a:schemeClr val="lt1"/>
+          </a:fontRef>
+        </p:style>
+        <p:txBody>
+          <a:bodyPr rtlCol="0" anchor="ctr" wrap="square" lIns="137160"/>
+          <a:lstStyle/>
+          <a:p>
+            <a:pPr algn="l"/>
+            <a:r>
+              <a:rPr sz="1300" b="1" i="0">
+                <a:solidFill>
+                  <a:srgbClr val="DC2626"/>
+                </a:solidFill>
+                <a:latin typeface="Calibri"/>
+              </a:rPr>
+              <a:t>VIDEO  </a:t>
+            </a:r>
+            <a:r>
+              <a:rPr sz="1400" b="0" i="0">
+                <a:solidFill>
+                  <a:srgbClr val="1F2937"/>
+                </a:solidFill>
+                <a:latin typeface="Calibri"/>
+              </a:rPr>
+              <a:t>Ejemplos de PC a Android: </a:t>
+            </a:r>
+            <a:r>
+              <a:rPr sz="1400" b="1" i="0" u="sng">
+                <a:solidFill>
+                  <a:srgbClr val="DC2626"/>
+                </a:solidFill>
+                <a:latin typeface="Calibri"/>
+                <a:hlinkClick r:id="rId2"/>
+              </a:rPr>
+              <a:t>Jadsa Games, Unity 6 (18 min)</a:t>
+            </a:r>
+            <a:r>
+              <a:rPr sz="1400" b="0" i="0">
+                <a:solidFill>
+                  <a:srgbClr val="1F2937"/>
+                </a:solidFill>
+                <a:latin typeface="Calibri"/>
+              </a:rPr>
+              <a:t> · </a:t>
+            </a:r>
+            <a:r>
+              <a:rPr sz="1400" b="1" i="0" u="sng">
+                <a:solidFill>
+                  <a:srgbClr val="DC2626"/>
+                </a:solidFill>
+                <a:latin typeface="Calibri"/>
+                <a:hlinkClick r:id="rId3"/>
+              </a:rPr>
+              <a:t>LuisCanary, .exe y .apk (13 min)</a:t>
+            </a:r>
+          </a:p>
+        </p:txBody>
+      </p:sp>
       <p:pic>
         <p:nvPicPr>
-          <p:cNvPr id="9" name="Picture 8" descr="u4-build-botones.png"/>
+          <p:cNvPr id="11" name="Picture 10" descr="u4-build-botones.png"/>
           <p:cNvPicPr>
             <a:picLocks noChangeAspect="1"/>
           </p:cNvPicPr>
           <p:nvPr/>
         </p:nvPicPr>
         <p:blipFill>
-          <a:blip r:embed="rId2"/>
+          <a:blip r:embed="rId4"/>
           <a:stretch>
             <a:fillRect/>
           </a:stretch>
         </p:blipFill>
         <p:spPr>
           <a:xfrm>
-            <a:off x="4739335" y="3163034"/>
+            <a:off x="4739335" y="2888714"/>
             <a:ext cx="6949440" cy="531932"/>
           </a:xfrm>
           <a:prstGeom prst="rect">
@@ -50829,13 +51615,13 @@
       </p:pic>
       <p:sp>
         <p:nvSpPr>
-          <p:cNvPr id="10" name="TextBox 9"/>
+          <p:cNvPr id="12" name="TextBox 11"/>
           <p:cNvSpPr txBox="1"/>
           <p:nvPr/>
         </p:nvSpPr>
         <p:spPr>
           <a:xfrm>
-            <a:off x="4739335" y="5623560"/>
+            <a:off x="4739335" y="5074920"/>
             <a:ext cx="6949440" cy="365760"/>
           </a:xfrm>
           <a:prstGeom prst="rect">
@@ -50864,14 +51650,14 @@
       </p:sp>
       <p:sp>
         <p:nvSpPr>
-          <p:cNvPr id="11" name="TextBox 10"/>
+          <p:cNvPr id="13" name="TextBox 12"/>
           <p:cNvSpPr txBox="1"/>
           <p:nvPr/>
         </p:nvSpPr>
         <p:spPr>
           <a:xfrm>
             <a:off x="502920" y="1234440"/>
-            <a:ext cx="3962095" cy="4754880"/>
+            <a:ext cx="3962095" cy="4206240"/>
           </a:xfrm>
           <a:prstGeom prst="rect">
             <a:avLst/>
@@ -51261,7 +52047,7 @@
                 </a:solidFill>
                 <a:latin typeface="Calibri"/>
               </a:rPr>
-              <a:t>63/63</a:t>
+              <a:t>63/65</a:t>
             </a:r>
           </a:p>
         </p:txBody>
@@ -51665,6 +52451,2069 @@
 </p:sld>
 </file>
 
+<file path=ppt/slides/slide64.xml><?xml version="1.0" encoding="utf-8"?>
+<p:sld xmlns:a="http://schemas.openxmlformats.org/drawingml/2006/main" xmlns:p="http://schemas.openxmlformats.org/presentationml/2006/main" xmlns:r="http://schemas.openxmlformats.org/officeDocument/2006/relationships">
+  <p:cSld>
+    <p:bg>
+      <p:bgPr>
+        <a:solidFill>
+          <a:srgbClr val="FFFFFF"/>
+        </a:solidFill>
+        <a:effectLst/>
+      </p:bgPr>
+    </p:bg>
+    <p:spTree>
+      <p:nvGrpSpPr>
+        <p:cNvPr id="1" name=""/>
+        <p:cNvGrpSpPr/>
+        <p:nvPr/>
+      </p:nvGrpSpPr>
+      <p:grpSpPr/>
+      <p:sp>
+        <p:nvSpPr>
+          <p:cNvPr id="2" name="Rectangle 1"/>
+          <p:cNvSpPr/>
+          <p:nvPr/>
+        </p:nvSpPr>
+        <p:spPr>
+          <a:xfrm>
+            <a:off x="0" y="0"/>
+            <a:ext cx="12191695" cy="960120"/>
+          </a:xfrm>
+          <a:prstGeom prst="rect">
+            <a:avLst/>
+          </a:prstGeom>
+          <a:solidFill>
+            <a:srgbClr val="1F2A44"/>
+          </a:solidFill>
+          <a:ln>
+            <a:noFill/>
+          </a:ln>
+          <a:effectLst/>
+        </p:spPr>
+        <p:style>
+          <a:lnRef idx="1">
+            <a:schemeClr val="accent1"/>
+          </a:lnRef>
+          <a:fillRef idx="3">
+            <a:schemeClr val="accent1"/>
+          </a:fillRef>
+          <a:effectRef idx="2">
+            <a:schemeClr val="accent1"/>
+          </a:effectRef>
+          <a:fontRef idx="minor">
+            <a:schemeClr val="lt1"/>
+          </a:fontRef>
+        </p:style>
+        <p:txBody>
+          <a:bodyPr rtlCol="0" anchor="ctr"/>
+          <a:lstStyle/>
+          <a:p>
+            <a:pPr algn="ctr"/>
+          </a:p>
+        </p:txBody>
+      </p:sp>
+      <p:sp>
+        <p:nvSpPr>
+          <p:cNvPr id="3" name="Rectangle 2"/>
+          <p:cNvSpPr/>
+          <p:nvPr/>
+        </p:nvSpPr>
+        <p:spPr>
+          <a:xfrm>
+            <a:off x="0" y="960120"/>
+            <a:ext cx="12191695" cy="38100"/>
+          </a:xfrm>
+          <a:prstGeom prst="rect">
+            <a:avLst/>
+          </a:prstGeom>
+          <a:solidFill>
+            <a:srgbClr val="0D9488"/>
+          </a:solidFill>
+          <a:ln>
+            <a:noFill/>
+          </a:ln>
+          <a:effectLst/>
+        </p:spPr>
+        <p:style>
+          <a:lnRef idx="1">
+            <a:schemeClr val="accent1"/>
+          </a:lnRef>
+          <a:fillRef idx="3">
+            <a:schemeClr val="accent1"/>
+          </a:fillRef>
+          <a:effectRef idx="2">
+            <a:schemeClr val="accent1"/>
+          </a:effectRef>
+          <a:fontRef idx="minor">
+            <a:schemeClr val="lt1"/>
+          </a:fontRef>
+        </p:style>
+        <p:txBody>
+          <a:bodyPr rtlCol="0" anchor="ctr"/>
+          <a:lstStyle/>
+          <a:p>
+            <a:pPr algn="ctr"/>
+          </a:p>
+        </p:txBody>
+      </p:sp>
+      <p:sp>
+        <p:nvSpPr>
+          <p:cNvPr id="4" name="Oval 3"/>
+          <p:cNvSpPr/>
+          <p:nvPr/>
+        </p:nvSpPr>
+        <p:spPr>
+          <a:xfrm>
+            <a:off x="274320" y="219456"/>
+            <a:ext cx="530352" cy="530352"/>
+          </a:xfrm>
+          <a:prstGeom prst="ellipse">
+            <a:avLst/>
+          </a:prstGeom>
+          <a:solidFill>
+            <a:srgbClr val="0D9488"/>
+          </a:solidFill>
+          <a:ln>
+            <a:noFill/>
+          </a:ln>
+          <a:effectLst/>
+        </p:spPr>
+        <p:style>
+          <a:lnRef idx="1">
+            <a:schemeClr val="accent1"/>
+          </a:lnRef>
+          <a:fillRef idx="3">
+            <a:schemeClr val="accent1"/>
+          </a:fillRef>
+          <a:effectRef idx="2">
+            <a:schemeClr val="accent1"/>
+          </a:effectRef>
+          <a:fontRef idx="minor">
+            <a:schemeClr val="lt1"/>
+          </a:fontRef>
+        </p:style>
+        <p:txBody>
+          <a:bodyPr rtlCol="0" anchor="ctr" lIns="0" rIns="0" tIns="0" bIns="0"/>
+          <a:lstStyle/>
+          <a:p>
+            <a:pPr algn="ctr"/>
+            <a:r>
+              <a:rPr sz="1600" b="1" i="0">
+                <a:solidFill>
+                  <a:srgbClr val="FFFFFF"/>
+                </a:solidFill>
+                <a:latin typeface="Calibri"/>
+              </a:rPr>
+              <a:t>64</a:t>
+            </a:r>
+          </a:p>
+        </p:txBody>
+      </p:sp>
+      <p:sp>
+        <p:nvSpPr>
+          <p:cNvPr id="5" name="TextBox 4"/>
+          <p:cNvSpPr txBox="1"/>
+          <p:nvPr/>
+        </p:nvSpPr>
+        <p:spPr>
+          <a:xfrm>
+            <a:off x="1005840" y="109728"/>
+            <a:ext cx="10728655" cy="777240"/>
+          </a:xfrm>
+          <a:prstGeom prst="rect">
+            <a:avLst/>
+          </a:prstGeom>
+          <a:noFill/>
+        </p:spPr>
+        <p:txBody>
+          <a:bodyPr wrap="square" anchor="ctr" lIns="0" rIns="0" tIns="0" bIns="0">
+            <a:spAutoFit/>
+          </a:bodyPr>
+          <a:lstStyle/>
+          <a:p>
+            <a:r>
+              <a:rPr sz="1100" b="1" i="0">
+                <a:solidFill>
+                  <a:srgbClr val="99F6E4"/>
+                </a:solidFill>
+                <a:latin typeface="Calibri"/>
+              </a:rPr>
+              <a:t>ANEXO · CASO 2D PLATFORMER · PC Y ANDROID</a:t>
+            </a:r>
+          </a:p>
+          <a:p>
+            <a:r>
+              <a:rPr sz="2600" b="1" i="0">
+                <a:solidFill>
+                  <a:srgbClr val="FFFFFF"/>
+                </a:solidFill>
+                <a:latin typeface="Calibri"/>
+              </a:rPr>
+              <a:t>Antes y después: controles</a:t>
+            </a:r>
+          </a:p>
+        </p:txBody>
+      </p:sp>
+      <p:sp>
+        <p:nvSpPr>
+          <p:cNvPr id="6" name="TextBox 5"/>
+          <p:cNvSpPr txBox="1"/>
+          <p:nvPr/>
+        </p:nvSpPr>
+        <p:spPr>
+          <a:xfrm>
+            <a:off x="502920" y="6473952"/>
+            <a:ext cx="11185855" cy="274320"/>
+          </a:xfrm>
+          <a:prstGeom prst="rect">
+            <a:avLst/>
+          </a:prstGeom>
+          <a:noFill/>
+        </p:spPr>
+        <p:txBody>
+          <a:bodyPr wrap="square" anchor="ctr" lIns="0" rIns="0" tIns="0" bIns="0">
+            <a:spAutoFit/>
+          </a:bodyPr>
+          <a:lstStyle/>
+          <a:p>
+            <a:r>
+              <a:rPr sz="1000" b="0" i="0">
+                <a:solidFill>
+                  <a:srgbClr val="6B7280"/>
+                </a:solidFill>
+                <a:latin typeface="Calibri"/>
+              </a:rPr>
+              <a:t>Diseño según Plataformas de Juego · Unidad IV · Anexo · Anexo: Android en Unity 6</a:t>
+            </a:r>
+          </a:p>
+        </p:txBody>
+      </p:sp>
+      <p:sp>
+        <p:nvSpPr>
+          <p:cNvPr id="7" name="TextBox 6"/>
+          <p:cNvSpPr txBox="1"/>
+          <p:nvPr/>
+        </p:nvSpPr>
+        <p:spPr>
+          <a:xfrm>
+            <a:off x="10774375" y="6473952"/>
+            <a:ext cx="914400" cy="274320"/>
+          </a:xfrm>
+          <a:prstGeom prst="rect">
+            <a:avLst/>
+          </a:prstGeom>
+          <a:noFill/>
+        </p:spPr>
+        <p:txBody>
+          <a:bodyPr wrap="square" anchor="ctr" lIns="0" rIns="0" tIns="0" bIns="0">
+            <a:spAutoFit/>
+          </a:bodyPr>
+          <a:lstStyle/>
+          <a:p>
+            <a:pPr algn="r"/>
+            <a:r>
+              <a:rPr sz="1000" b="0" i="0">
+                <a:solidFill>
+                  <a:srgbClr val="6B7280"/>
+                </a:solidFill>
+                <a:latin typeface="Calibri"/>
+              </a:rPr>
+              <a:t>64/65</a:t>
+            </a:r>
+          </a:p>
+        </p:txBody>
+      </p:sp>
+      <p:sp>
+        <p:nvSpPr>
+          <p:cNvPr id="8" name="TextBox 7"/>
+          <p:cNvSpPr txBox="1"/>
+          <p:nvPr/>
+        </p:nvSpPr>
+        <p:spPr>
+          <a:xfrm>
+            <a:off x="502920" y="6126480"/>
+            <a:ext cx="11185855" cy="292608"/>
+          </a:xfrm>
+          <a:prstGeom prst="rect">
+            <a:avLst/>
+          </a:prstGeom>
+          <a:noFill/>
+        </p:spPr>
+        <p:txBody>
+          <a:bodyPr wrap="square" anchor="ctr" lIns="0" rIns="0" tIns="0" bIns="0">
+            <a:spAutoFit/>
+          </a:bodyPr>
+          <a:lstStyle/>
+          <a:p>
+            <a:r>
+              <a:rPr sz="1000" b="1" i="0">
+                <a:solidFill>
+                  <a:srgbClr val="6B7280"/>
+                </a:solidFill>
+                <a:latin typeface="Calibri"/>
+              </a:rPr>
+              <a:t>Fuente: </a:t>
+            </a:r>
+            <a:r>
+              <a:rPr sz="1000" b="0" i="0">
+                <a:solidFill>
+                  <a:srgbClr val="6B7280"/>
+                </a:solidFill>
+                <a:latin typeface="Calibri"/>
+              </a:rPr>
+              <a:t>proyectos-unity/2D-Platformer-Unity-v2; laboratorio-adaptacion/PORTEO-PLATFORMER.md (evidencia del 19/10/2026)</a:t>
+            </a:r>
+          </a:p>
+        </p:txBody>
+      </p:sp>
+      <p:sp>
+        <p:nvSpPr>
+          <p:cNvPr id="9" name="Rectangle 8"/>
+          <p:cNvSpPr/>
+          <p:nvPr/>
+        </p:nvSpPr>
+        <p:spPr>
+          <a:xfrm>
+            <a:off x="502920" y="5577840"/>
+            <a:ext cx="109728" cy="457200"/>
+          </a:xfrm>
+          <a:prstGeom prst="rect">
+            <a:avLst/>
+          </a:prstGeom>
+          <a:solidFill>
+            <a:srgbClr val="D97706"/>
+          </a:solidFill>
+          <a:ln>
+            <a:noFill/>
+          </a:ln>
+          <a:effectLst/>
+        </p:spPr>
+        <p:style>
+          <a:lnRef idx="1">
+            <a:schemeClr val="accent1"/>
+          </a:lnRef>
+          <a:fillRef idx="3">
+            <a:schemeClr val="accent1"/>
+          </a:fillRef>
+          <a:effectRef idx="2">
+            <a:schemeClr val="accent1"/>
+          </a:effectRef>
+          <a:fontRef idx="minor">
+            <a:schemeClr val="lt1"/>
+          </a:fontRef>
+        </p:style>
+        <p:txBody>
+          <a:bodyPr rtlCol="0" anchor="ctr"/>
+          <a:lstStyle/>
+          <a:p>
+            <a:pPr algn="ctr"/>
+          </a:p>
+        </p:txBody>
+      </p:sp>
+      <p:sp>
+        <p:nvSpPr>
+          <p:cNvPr id="10" name="Rectangle 9"/>
+          <p:cNvSpPr/>
+          <p:nvPr/>
+        </p:nvSpPr>
+        <p:spPr>
+          <a:xfrm>
+            <a:off x="612648" y="5577840"/>
+            <a:ext cx="11076127" cy="457200"/>
+          </a:xfrm>
+          <a:prstGeom prst="rect">
+            <a:avLst/>
+          </a:prstGeom>
+          <a:solidFill>
+            <a:srgbClr val="F3F4F6"/>
+          </a:solidFill>
+          <a:ln>
+            <a:noFill/>
+          </a:ln>
+          <a:effectLst/>
+        </p:spPr>
+        <p:style>
+          <a:lnRef idx="1">
+            <a:schemeClr val="accent1"/>
+          </a:lnRef>
+          <a:fillRef idx="3">
+            <a:schemeClr val="accent1"/>
+          </a:fillRef>
+          <a:effectRef idx="2">
+            <a:schemeClr val="accent1"/>
+          </a:effectRef>
+          <a:fontRef idx="minor">
+            <a:schemeClr val="lt1"/>
+          </a:fontRef>
+        </p:style>
+        <p:txBody>
+          <a:bodyPr rtlCol="0" anchor="ctr" wrap="square" lIns="137160"/>
+          <a:lstStyle/>
+          <a:p>
+            <a:pPr algn="l"/>
+            <a:r>
+              <a:rPr sz="1300" b="1" i="0">
+                <a:solidFill>
+                  <a:srgbClr val="D97706"/>
+                </a:solidFill>
+                <a:latin typeface="Calibri"/>
+              </a:rPr>
+              <a:t>PREGUNTA  </a:t>
+            </a:r>
+            <a:r>
+              <a:rPr sz="1400" b="0" i="0">
+                <a:solidFill>
+                  <a:srgbClr val="1F2937"/>
+                </a:solidFill>
+                <a:latin typeface="Calibri"/>
+              </a:rPr>
+              <a:t>¿Qué cambió para quien juega en PC?</a:t>
+            </a:r>
+          </a:p>
+        </p:txBody>
+      </p:sp>
+      <p:graphicFrame>
+        <p:nvGraphicFramePr>
+          <p:cNvPr id="11" name="Table 10"/>
+          <p:cNvGraphicFramePr>
+            <a:graphicFrameLocks noGrp="1"/>
+          </p:cNvGraphicFramePr>
+          <p:nvPr/>
+        </p:nvGraphicFramePr>
+        <p:xfrm>
+          <a:off x="502920" y="1234440"/>
+          <a:ext cx="11185852" cy="2834640"/>
+        </p:xfrm>
+        <a:graphic>
+          <a:graphicData uri="http://schemas.openxmlformats.org/drawingml/2006/table">
+            <a:tbl>
+              <a:tblPr firstRow="1" bandRow="1">
+                <a:tableStyleId>{5C22544A-7EE6-4342-B048-85BDC9FD1C3A}</a:tableStyleId>
+              </a:tblPr>
+              <a:tblGrid>
+                <a:gridCol w="1618079"/>
+                <a:gridCol w="2321592"/>
+                <a:gridCol w="2180889"/>
+                <a:gridCol w="1618079"/>
+                <a:gridCol w="1969836"/>
+                <a:gridCol w="1477377"/>
+              </a:tblGrid>
+              <a:tr h="566928">
+                <a:tc>
+                  <a:txBody>
+                    <a:bodyPr wrap="square"/>
+                    <a:lstStyle/>
+                    <a:p>
+                      <a:r>
+                        <a:rPr sz="1400" b="1" i="0">
+                          <a:solidFill>
+                            <a:srgbClr val="FFFFFF"/>
+                          </a:solidFill>
+                          <a:latin typeface="Calibri"/>
+                        </a:rPr>
+                        <a:t>Versión</a:t>
+                      </a:r>
+                    </a:p>
+                  </a:txBody>
+                  <a:tcPr marL="73152" marR="73152" marT="36576" marB="36576" anchor="ctr">
+                    <a:solidFill>
+                      <a:srgbClr val="0D9488"/>
+                    </a:solidFill>
+                  </a:tcPr>
+                </a:tc>
+                <a:tc>
+                  <a:txBody>
+                    <a:bodyPr wrap="square"/>
+                    <a:lstStyle/>
+                    <a:p>
+                      <a:r>
+                        <a:rPr sz="1400" b="1" i="0">
+                          <a:solidFill>
+                            <a:srgbClr val="FFFFFF"/>
+                          </a:solidFill>
+                          <a:latin typeface="Calibri"/>
+                        </a:rPr>
+                        <a:t>Controles</a:t>
+                      </a:r>
+                    </a:p>
+                  </a:txBody>
+                  <a:tcPr marL="73152" marR="73152" marT="36576" marB="36576" anchor="ctr">
+                    <a:solidFill>
+                      <a:srgbClr val="0D9488"/>
+                    </a:solidFill>
+                  </a:tcPr>
+                </a:tc>
+                <a:tc>
+                  <a:txBody>
+                    <a:bodyPr wrap="square"/>
+                    <a:lstStyle/>
+                    <a:p>
+                      <a:r>
+                        <a:rPr sz="1400" b="1" i="0">
+                          <a:solidFill>
+                            <a:srgbClr val="FFFFFF"/>
+                          </a:solidFill>
+                          <a:latin typeface="Calibri"/>
+                        </a:rPr>
+                        <a:t>Mover</a:t>
+                      </a:r>
+                    </a:p>
+                  </a:txBody>
+                  <a:tcPr marL="73152" marR="73152" marT="36576" marB="36576" anchor="ctr">
+                    <a:solidFill>
+                      <a:srgbClr val="0D9488"/>
+                    </a:solidFill>
+                  </a:tcPr>
+                </a:tc>
+                <a:tc>
+                  <a:txBody>
+                    <a:bodyPr wrap="square"/>
+                    <a:lstStyle/>
+                    <a:p>
+                      <a:r>
+                        <a:rPr sz="1400" b="1" i="0">
+                          <a:solidFill>
+                            <a:srgbClr val="FFFFFF"/>
+                          </a:solidFill>
+                          <a:latin typeface="Calibri"/>
+                        </a:rPr>
+                        <a:t>Saltar</a:t>
+                      </a:r>
+                    </a:p>
+                  </a:txBody>
+                  <a:tcPr marL="73152" marR="73152" marT="36576" marB="36576" anchor="ctr">
+                    <a:solidFill>
+                      <a:srgbClr val="0D9488"/>
+                    </a:solidFill>
+                  </a:tcPr>
+                </a:tc>
+                <a:tc>
+                  <a:txBody>
+                    <a:bodyPr wrap="square"/>
+                    <a:lstStyle/>
+                    <a:p>
+                      <a:r>
+                        <a:rPr sz="1400" b="1" i="0">
+                          <a:solidFill>
+                            <a:srgbClr val="FFFFFF"/>
+                          </a:solidFill>
+                          <a:latin typeface="Calibri"/>
+                        </a:rPr>
+                        <a:t>En pantalla</a:t>
+                      </a:r>
+                    </a:p>
+                  </a:txBody>
+                  <a:tcPr marL="73152" marR="73152" marT="36576" marB="36576" anchor="ctr">
+                    <a:solidFill>
+                      <a:srgbClr val="0D9488"/>
+                    </a:solidFill>
+                  </a:tcPr>
+                </a:tc>
+                <a:tc>
+                  <a:txBody>
+                    <a:bodyPr wrap="square"/>
+                    <a:lstStyle/>
+                    <a:p>
+                      <a:r>
+                        <a:rPr sz="1400" b="1" i="0">
+                          <a:solidFill>
+                            <a:srgbClr val="FFFFFF"/>
+                          </a:solidFill>
+                          <a:latin typeface="Calibri"/>
+                        </a:rPr>
+                        <a:t>Orientación</a:t>
+                      </a:r>
+                    </a:p>
+                  </a:txBody>
+                  <a:tcPr marL="73152" marR="73152" marT="36576" marB="36576" anchor="ctr">
+                    <a:solidFill>
+                      <a:srgbClr val="0D9488"/>
+                    </a:solidFill>
+                  </a:tcPr>
+                </a:tc>
+              </a:tr>
+              <a:tr h="566928">
+                <a:tc>
+                  <a:txBody>
+                    <a:bodyPr wrap="square"/>
+                    <a:lstStyle/>
+                    <a:p>
+                      <a:r>
+                        <a:rPr sz="1400" b="0" i="0">
+                          <a:solidFill>
+                            <a:srgbClr val="1F2937"/>
+                          </a:solidFill>
+                          <a:latin typeface="Calibri"/>
+                        </a:rPr>
+                        <a:t>PC · antes</a:t>
+                      </a:r>
+                    </a:p>
+                  </a:txBody>
+                  <a:tcPr marL="73152" marR="73152" marT="36576" marB="36576" anchor="ctr">
+                    <a:solidFill>
+                      <a:srgbClr val="FFFFFF"/>
+                    </a:solidFill>
+                  </a:tcPr>
+                </a:tc>
+                <a:tc>
+                  <a:txBody>
+                    <a:bodyPr wrap="square"/>
+                    <a:lstStyle/>
+                    <a:p>
+                      <a:r>
+                        <a:rPr sz="1400" b="0" i="0">
+                          <a:solidFill>
+                            <a:srgbClr val="1F2937"/>
+                          </a:solidFill>
+                          <a:latin typeface="Calibri"/>
+                        </a:rPr>
+                        <a:t>Teclado y joystick (legacy)</a:t>
+                      </a:r>
+                    </a:p>
+                  </a:txBody>
+                  <a:tcPr marL="73152" marR="73152" marT="36576" marB="36576" anchor="ctr">
+                    <a:solidFill>
+                      <a:srgbClr val="FFFFFF"/>
+                    </a:solidFill>
+                  </a:tcPr>
+                </a:tc>
+                <a:tc>
+                  <a:txBody>
+                    <a:bodyPr wrap="square"/>
+                    <a:lstStyle/>
+                    <a:p>
+                      <a:r>
+                        <a:rPr sz="1400" b="0" i="0">
+                          <a:solidFill>
+                            <a:srgbClr val="1F2937"/>
+                          </a:solidFill>
+                          <a:latin typeface="Calibri"/>
+                        </a:rPr>
+                        <a:t>← → / A D, con suavizado</a:t>
+                      </a:r>
+                    </a:p>
+                  </a:txBody>
+                  <a:tcPr marL="73152" marR="73152" marT="36576" marB="36576" anchor="ctr">
+                    <a:solidFill>
+                      <a:srgbClr val="FFFFFF"/>
+                    </a:solidFill>
+                  </a:tcPr>
+                </a:tc>
+                <a:tc>
+                  <a:txBody>
+                    <a:bodyPr wrap="square"/>
+                    <a:lstStyle/>
+                    <a:p>
+                      <a:r>
+                        <a:rPr sz="1400" b="0" i="0">
+                          <a:solidFill>
+                            <a:srgbClr val="1F2937"/>
+                          </a:solidFill>
+                          <a:latin typeface="Calibri"/>
+                        </a:rPr>
+                        <a:t>Espacio</a:t>
+                      </a:r>
+                    </a:p>
+                  </a:txBody>
+                  <a:tcPr marL="73152" marR="73152" marT="36576" marB="36576" anchor="ctr">
+                    <a:solidFill>
+                      <a:srgbClr val="FFFFFF"/>
+                    </a:solidFill>
+                  </a:tcPr>
+                </a:tc>
+                <a:tc>
+                  <a:txBody>
+                    <a:bodyPr wrap="square"/>
+                    <a:lstStyle/>
+                    <a:p>
+                      <a:r>
+                        <a:rPr sz="1400" b="0" i="0">
+                          <a:solidFill>
+                            <a:srgbClr val="1F2937"/>
+                          </a:solidFill>
+                          <a:latin typeface="Calibri"/>
+                        </a:rPr>
+                        <a:t>Nada</a:t>
+                      </a:r>
+                    </a:p>
+                  </a:txBody>
+                  <a:tcPr marL="73152" marR="73152" marT="36576" marB="36576" anchor="ctr">
+                    <a:solidFill>
+                      <a:srgbClr val="FFFFFF"/>
+                    </a:solidFill>
+                  </a:tcPr>
+                </a:tc>
+                <a:tc>
+                  <a:txBody>
+                    <a:bodyPr wrap="square"/>
+                    <a:lstStyle/>
+                    <a:p>
+                      <a:r>
+                        <a:rPr sz="1400" b="0" i="0">
+                          <a:solidFill>
+                            <a:srgbClr val="1F2937"/>
+                          </a:solidFill>
+                          <a:latin typeface="Calibri"/>
+                        </a:rPr>
+                        <a:t>Ventana</a:t>
+                      </a:r>
+                    </a:p>
+                  </a:txBody>
+                  <a:tcPr marL="73152" marR="73152" marT="36576" marB="36576" anchor="ctr">
+                    <a:solidFill>
+                      <a:srgbClr val="FFFFFF"/>
+                    </a:solidFill>
+                  </a:tcPr>
+                </a:tc>
+              </a:tr>
+              <a:tr h="566928">
+                <a:tc>
+                  <a:txBody>
+                    <a:bodyPr wrap="square"/>
+                    <a:lstStyle/>
+                    <a:p>
+                      <a:r>
+                        <a:rPr sz="1400" b="0" i="0">
+                          <a:solidFill>
+                            <a:srgbClr val="1F2937"/>
+                          </a:solidFill>
+                          <a:latin typeface="Calibri"/>
+                        </a:rPr>
+                        <a:t>PC · después</a:t>
+                      </a:r>
+                    </a:p>
+                  </a:txBody>
+                  <a:tcPr marL="73152" marR="73152" marT="36576" marB="36576" anchor="ctr">
+                    <a:solidFill>
+                      <a:srgbClr val="E6F4F2"/>
+                    </a:solidFill>
+                  </a:tcPr>
+                </a:tc>
+                <a:tc>
+                  <a:txBody>
+                    <a:bodyPr wrap="square"/>
+                    <a:lstStyle/>
+                    <a:p>
+                      <a:r>
+                        <a:rPr sz="1400" b="0" i="0">
+                          <a:solidFill>
+                            <a:srgbClr val="1F2937"/>
+                          </a:solidFill>
+                          <a:latin typeface="Calibri"/>
+                        </a:rPr>
+                        <a:t>Teclado y gamepad</a:t>
+                      </a:r>
+                    </a:p>
+                  </a:txBody>
+                  <a:tcPr marL="73152" marR="73152" marT="36576" marB="36576" anchor="ctr">
+                    <a:solidFill>
+                      <a:srgbClr val="E6F4F2"/>
+                    </a:solidFill>
+                  </a:tcPr>
+                </a:tc>
+                <a:tc>
+                  <a:txBody>
+                    <a:bodyPr wrap="square"/>
+                    <a:lstStyle/>
+                    <a:p>
+                      <a:r>
+                        <a:rPr sz="1400" b="0" i="0">
+                          <a:solidFill>
+                            <a:srgbClr val="1F2937"/>
+                          </a:solidFill>
+                          <a:latin typeface="Calibri"/>
+                        </a:rPr>
+                        <a:t>← → / A D, stick, cruceta</a:t>
+                      </a:r>
+                    </a:p>
+                  </a:txBody>
+                  <a:tcPr marL="73152" marR="73152" marT="36576" marB="36576" anchor="ctr">
+                    <a:solidFill>
+                      <a:srgbClr val="E6F4F2"/>
+                    </a:solidFill>
+                  </a:tcPr>
+                </a:tc>
+                <a:tc>
+                  <a:txBody>
+                    <a:bodyPr wrap="square"/>
+                    <a:lstStyle/>
+                    <a:p>
+                      <a:r>
+                        <a:rPr sz="1400" b="0" i="0">
+                          <a:solidFill>
+                            <a:srgbClr val="1F2937"/>
+                          </a:solidFill>
+                          <a:latin typeface="Calibri"/>
+                        </a:rPr>
+                        <a:t>Espacio o botón A</a:t>
+                      </a:r>
+                    </a:p>
+                  </a:txBody>
+                  <a:tcPr marL="73152" marR="73152" marT="36576" marB="36576" anchor="ctr">
+                    <a:solidFill>
+                      <a:srgbClr val="E6F4F2"/>
+                    </a:solidFill>
+                  </a:tcPr>
+                </a:tc>
+                <a:tc>
+                  <a:txBody>
+                    <a:bodyPr wrap="square"/>
+                    <a:lstStyle/>
+                    <a:p>
+                      <a:r>
+                        <a:rPr sz="1400" b="0" i="0">
+                          <a:solidFill>
+                            <a:srgbClr val="1F2937"/>
+                          </a:solidFill>
+                          <a:latin typeface="Calibri"/>
+                        </a:rPr>
+                        <a:t>Nada (oculto)</a:t>
+                      </a:r>
+                    </a:p>
+                  </a:txBody>
+                  <a:tcPr marL="73152" marR="73152" marT="36576" marB="36576" anchor="ctr">
+                    <a:solidFill>
+                      <a:srgbClr val="E6F4F2"/>
+                    </a:solidFill>
+                  </a:tcPr>
+                </a:tc>
+                <a:tc>
+                  <a:txBody>
+                    <a:bodyPr wrap="square"/>
+                    <a:lstStyle/>
+                    <a:p>
+                      <a:r>
+                        <a:rPr sz="1400" b="0" i="0">
+                          <a:solidFill>
+                            <a:srgbClr val="1F2937"/>
+                          </a:solidFill>
+                          <a:latin typeface="Calibri"/>
+                        </a:rPr>
+                        <a:t>Ventana</a:t>
+                      </a:r>
+                    </a:p>
+                  </a:txBody>
+                  <a:tcPr marL="73152" marR="73152" marT="36576" marB="36576" anchor="ctr">
+                    <a:solidFill>
+                      <a:srgbClr val="E6F4F2"/>
+                    </a:solidFill>
+                  </a:tcPr>
+                </a:tc>
+              </a:tr>
+              <a:tr h="566928">
+                <a:tc>
+                  <a:txBody>
+                    <a:bodyPr wrap="square"/>
+                    <a:lstStyle/>
+                    <a:p>
+                      <a:r>
+                        <a:rPr sz="1400" b="0" i="0">
+                          <a:solidFill>
+                            <a:srgbClr val="1F2937"/>
+                          </a:solidFill>
+                          <a:latin typeface="Calibri"/>
+                        </a:rPr>
+                        <a:t>Android · antes</a:t>
+                      </a:r>
+                    </a:p>
+                  </a:txBody>
+                  <a:tcPr marL="73152" marR="73152" marT="36576" marB="36576" anchor="ctr">
+                    <a:solidFill>
+                      <a:srgbClr val="FFFFFF"/>
+                    </a:solidFill>
+                  </a:tcPr>
+                </a:tc>
+                <a:tc>
+                  <a:txBody>
+                    <a:bodyPr wrap="square"/>
+                    <a:lstStyle/>
+                    <a:p>
+                      <a:r>
+                        <a:rPr sz="1400" b="0" i="0">
+                          <a:solidFill>
+                            <a:srgbClr val="1F2937"/>
+                          </a:solidFill>
+                          <a:latin typeface="Calibri"/>
+                        </a:rPr>
+                        <a:t>Ninguno</a:t>
+                      </a:r>
+                    </a:p>
+                  </a:txBody>
+                  <a:tcPr marL="73152" marR="73152" marT="36576" marB="36576" anchor="ctr">
+                    <a:solidFill>
+                      <a:srgbClr val="FFFFFF"/>
+                    </a:solidFill>
+                  </a:tcPr>
+                </a:tc>
+                <a:tc>
+                  <a:txBody>
+                    <a:bodyPr wrap="square"/>
+                    <a:lstStyle/>
+                    <a:p>
+                      <a:r>
+                        <a:rPr sz="1400" b="0" i="0">
+                          <a:solidFill>
+                            <a:srgbClr val="1F2937"/>
+                          </a:solidFill>
+                          <a:latin typeface="Calibri"/>
+                        </a:rPr>
+                        <a:t>No se puede</a:t>
+                      </a:r>
+                    </a:p>
+                  </a:txBody>
+                  <a:tcPr marL="73152" marR="73152" marT="36576" marB="36576" anchor="ctr">
+                    <a:solidFill>
+                      <a:srgbClr val="FFFFFF"/>
+                    </a:solidFill>
+                  </a:tcPr>
+                </a:tc>
+                <a:tc>
+                  <a:txBody>
+                    <a:bodyPr wrap="square"/>
+                    <a:lstStyle/>
+                    <a:p>
+                      <a:r>
+                        <a:rPr sz="1400" b="0" i="0">
+                          <a:solidFill>
+                            <a:srgbClr val="1F2937"/>
+                          </a:solidFill>
+                          <a:latin typeface="Calibri"/>
+                        </a:rPr>
+                        <a:t>No se puede</a:t>
+                      </a:r>
+                    </a:p>
+                  </a:txBody>
+                  <a:tcPr marL="73152" marR="73152" marT="36576" marB="36576" anchor="ctr">
+                    <a:solidFill>
+                      <a:srgbClr val="FFFFFF"/>
+                    </a:solidFill>
+                  </a:tcPr>
+                </a:tc>
+                <a:tc>
+                  <a:txBody>
+                    <a:bodyPr wrap="square"/>
+                    <a:lstStyle/>
+                    <a:p>
+                      <a:r>
+                        <a:rPr sz="1400" b="0" i="0">
+                          <a:solidFill>
+                            <a:srgbClr val="1F2937"/>
+                          </a:solidFill>
+                          <a:latin typeface="Calibri"/>
+                        </a:rPr>
+                        <a:t>Contenedor vacío</a:t>
+                      </a:r>
+                    </a:p>
+                  </a:txBody>
+                  <a:tcPr marL="73152" marR="73152" marT="36576" marB="36576" anchor="ctr">
+                    <a:solidFill>
+                      <a:srgbClr val="FFFFFF"/>
+                    </a:solidFill>
+                  </a:tcPr>
+                </a:tc>
+                <a:tc>
+                  <a:txBody>
+                    <a:bodyPr wrap="square"/>
+                    <a:lstStyle/>
+                    <a:p>
+                      <a:r>
+                        <a:rPr sz="1400" b="0" i="0">
+                          <a:solidFill>
+                            <a:srgbClr val="1F2937"/>
+                          </a:solidFill>
+                          <a:latin typeface="Calibri"/>
+                        </a:rPr>
+                        <a:t>Las 4</a:t>
+                      </a:r>
+                    </a:p>
+                  </a:txBody>
+                  <a:tcPr marL="73152" marR="73152" marT="36576" marB="36576" anchor="ctr">
+                    <a:solidFill>
+                      <a:srgbClr val="FFFFFF"/>
+                    </a:solidFill>
+                  </a:tcPr>
+                </a:tc>
+              </a:tr>
+              <a:tr h="566928">
+                <a:tc>
+                  <a:txBody>
+                    <a:bodyPr wrap="square"/>
+                    <a:lstStyle/>
+                    <a:p>
+                      <a:r>
+                        <a:rPr sz="1400" b="0" i="0">
+                          <a:solidFill>
+                            <a:srgbClr val="1F2937"/>
+                          </a:solidFill>
+                          <a:latin typeface="Calibri"/>
+                        </a:rPr>
+                        <a:t>Android · después</a:t>
+                      </a:r>
+                    </a:p>
+                  </a:txBody>
+                  <a:tcPr marL="73152" marR="73152" marT="36576" marB="36576" anchor="ctr">
+                    <a:solidFill>
+                      <a:srgbClr val="E6F4F2"/>
+                    </a:solidFill>
+                  </a:tcPr>
+                </a:tc>
+                <a:tc>
+                  <a:txBody>
+                    <a:bodyPr wrap="square"/>
+                    <a:lstStyle/>
+                    <a:p>
+                      <a:r>
+                        <a:rPr sz="1400" b="0" i="0">
+                          <a:solidFill>
+                            <a:srgbClr val="1F2937"/>
+                          </a:solidFill>
+                          <a:latin typeface="Calibri"/>
+                        </a:rPr>
+                        <a:t>Táctil = gamepad virtual</a:t>
+                      </a:r>
+                    </a:p>
+                  </a:txBody>
+                  <a:tcPr marL="73152" marR="73152" marT="36576" marB="36576" anchor="ctr">
+                    <a:solidFill>
+                      <a:srgbClr val="E6F4F2"/>
+                    </a:solidFill>
+                  </a:tcPr>
+                </a:tc>
+                <a:tc>
+                  <a:txBody>
+                    <a:bodyPr wrap="square"/>
+                    <a:lstStyle/>
+                    <a:p>
+                      <a:r>
+                        <a:rPr sz="1400" b="0" i="0">
+                          <a:solidFill>
+                            <a:srgbClr val="1F2937"/>
+                          </a:solidFill>
+                          <a:latin typeface="Calibri"/>
+                        </a:rPr>
+                        <a:t>Botones ◀ ▶</a:t>
+                      </a:r>
+                    </a:p>
+                  </a:txBody>
+                  <a:tcPr marL="73152" marR="73152" marT="36576" marB="36576" anchor="ctr">
+                    <a:solidFill>
+                      <a:srgbClr val="E6F4F2"/>
+                    </a:solidFill>
+                  </a:tcPr>
+                </a:tc>
+                <a:tc>
+                  <a:txBody>
+                    <a:bodyPr wrap="square"/>
+                    <a:lstStyle/>
+                    <a:p>
+                      <a:r>
+                        <a:rPr sz="1400" b="0" i="0">
+                          <a:solidFill>
+                            <a:srgbClr val="1F2937"/>
+                          </a:solidFill>
+                          <a:latin typeface="Calibri"/>
+                        </a:rPr>
+                        <a:t>Botón SALTAR</a:t>
+                      </a:r>
+                    </a:p>
+                  </a:txBody>
+                  <a:tcPr marL="73152" marR="73152" marT="36576" marB="36576" anchor="ctr">
+                    <a:solidFill>
+                      <a:srgbClr val="E6F4F2"/>
+                    </a:solidFill>
+                  </a:tcPr>
+                </a:tc>
+                <a:tc>
+                  <a:txBody>
+                    <a:bodyPr wrap="square"/>
+                    <a:lstStyle/>
+                    <a:p>
+                      <a:r>
+                        <a:rPr sz="1400" b="0" i="0">
+                          <a:solidFill>
+                            <a:srgbClr val="1F2937"/>
+                          </a:solidFill>
+                          <a:latin typeface="Calibri"/>
+                        </a:rPr>
+                        <a:t>◀ ▶ SALTAR + safe area</a:t>
+                      </a:r>
+                    </a:p>
+                  </a:txBody>
+                  <a:tcPr marL="73152" marR="73152" marT="36576" marB="36576" anchor="ctr">
+                    <a:solidFill>
+                      <a:srgbClr val="E6F4F2"/>
+                    </a:solidFill>
+                  </a:tcPr>
+                </a:tc>
+                <a:tc>
+                  <a:txBody>
+                    <a:bodyPr wrap="square"/>
+                    <a:lstStyle/>
+                    <a:p>
+                      <a:r>
+                        <a:rPr sz="1400" b="0" i="0">
+                          <a:solidFill>
+                            <a:srgbClr val="1F2937"/>
+                          </a:solidFill>
+                          <a:latin typeface="Calibri"/>
+                        </a:rPr>
+                        <a:t>Solo horizontal</a:t>
+                      </a:r>
+                    </a:p>
+                  </a:txBody>
+                  <a:tcPr marL="73152" marR="73152" marT="36576" marB="36576" anchor="ctr">
+                    <a:solidFill>
+                      <a:srgbClr val="E6F4F2"/>
+                    </a:solidFill>
+                  </a:tcPr>
+                </a:tc>
+              </a:tr>
+            </a:tbl>
+          </a:graphicData>
+        </a:graphic>
+      </p:graphicFrame>
+    </p:spTree>
+  </p:cSld>
+  <p:clrMapOvr>
+    <a:masterClrMapping/>
+  </p:clrMapOvr>
+</p:sld>
+</file>
+
+<file path=ppt/slides/slide65.xml><?xml version="1.0" encoding="utf-8"?>
+<p:sld xmlns:a="http://schemas.openxmlformats.org/drawingml/2006/main" xmlns:p="http://schemas.openxmlformats.org/presentationml/2006/main" xmlns:r="http://schemas.openxmlformats.org/officeDocument/2006/relationships">
+  <p:cSld>
+    <p:bg>
+      <p:bgPr>
+        <a:solidFill>
+          <a:srgbClr val="FFFFFF"/>
+        </a:solidFill>
+        <a:effectLst/>
+      </p:bgPr>
+    </p:bg>
+    <p:spTree>
+      <p:nvGrpSpPr>
+        <p:cNvPr id="1" name=""/>
+        <p:cNvGrpSpPr/>
+        <p:nvPr/>
+      </p:nvGrpSpPr>
+      <p:grpSpPr/>
+      <p:sp>
+        <p:nvSpPr>
+          <p:cNvPr id="2" name="Rectangle 1"/>
+          <p:cNvSpPr/>
+          <p:nvPr/>
+        </p:nvSpPr>
+        <p:spPr>
+          <a:xfrm>
+            <a:off x="0" y="0"/>
+            <a:ext cx="12191695" cy="960120"/>
+          </a:xfrm>
+          <a:prstGeom prst="rect">
+            <a:avLst/>
+          </a:prstGeom>
+          <a:solidFill>
+            <a:srgbClr val="1F2A44"/>
+          </a:solidFill>
+          <a:ln>
+            <a:noFill/>
+          </a:ln>
+          <a:effectLst/>
+        </p:spPr>
+        <p:style>
+          <a:lnRef idx="1">
+            <a:schemeClr val="accent1"/>
+          </a:lnRef>
+          <a:fillRef idx="3">
+            <a:schemeClr val="accent1"/>
+          </a:fillRef>
+          <a:effectRef idx="2">
+            <a:schemeClr val="accent1"/>
+          </a:effectRef>
+          <a:fontRef idx="minor">
+            <a:schemeClr val="lt1"/>
+          </a:fontRef>
+        </p:style>
+        <p:txBody>
+          <a:bodyPr rtlCol="0" anchor="ctr"/>
+          <a:lstStyle/>
+          <a:p>
+            <a:pPr algn="ctr"/>
+          </a:p>
+        </p:txBody>
+      </p:sp>
+      <p:sp>
+        <p:nvSpPr>
+          <p:cNvPr id="3" name="Rectangle 2"/>
+          <p:cNvSpPr/>
+          <p:nvPr/>
+        </p:nvSpPr>
+        <p:spPr>
+          <a:xfrm>
+            <a:off x="0" y="960120"/>
+            <a:ext cx="12191695" cy="38100"/>
+          </a:xfrm>
+          <a:prstGeom prst="rect">
+            <a:avLst/>
+          </a:prstGeom>
+          <a:solidFill>
+            <a:srgbClr val="0D9488"/>
+          </a:solidFill>
+          <a:ln>
+            <a:noFill/>
+          </a:ln>
+          <a:effectLst/>
+        </p:spPr>
+        <p:style>
+          <a:lnRef idx="1">
+            <a:schemeClr val="accent1"/>
+          </a:lnRef>
+          <a:fillRef idx="3">
+            <a:schemeClr val="accent1"/>
+          </a:fillRef>
+          <a:effectRef idx="2">
+            <a:schemeClr val="accent1"/>
+          </a:effectRef>
+          <a:fontRef idx="minor">
+            <a:schemeClr val="lt1"/>
+          </a:fontRef>
+        </p:style>
+        <p:txBody>
+          <a:bodyPr rtlCol="0" anchor="ctr"/>
+          <a:lstStyle/>
+          <a:p>
+            <a:pPr algn="ctr"/>
+          </a:p>
+        </p:txBody>
+      </p:sp>
+      <p:sp>
+        <p:nvSpPr>
+          <p:cNvPr id="4" name="Oval 3"/>
+          <p:cNvSpPr/>
+          <p:nvPr/>
+        </p:nvSpPr>
+        <p:spPr>
+          <a:xfrm>
+            <a:off x="274320" y="219456"/>
+            <a:ext cx="530352" cy="530352"/>
+          </a:xfrm>
+          <a:prstGeom prst="ellipse">
+            <a:avLst/>
+          </a:prstGeom>
+          <a:solidFill>
+            <a:srgbClr val="0D9488"/>
+          </a:solidFill>
+          <a:ln>
+            <a:noFill/>
+          </a:ln>
+          <a:effectLst/>
+        </p:spPr>
+        <p:style>
+          <a:lnRef idx="1">
+            <a:schemeClr val="accent1"/>
+          </a:lnRef>
+          <a:fillRef idx="3">
+            <a:schemeClr val="accent1"/>
+          </a:fillRef>
+          <a:effectRef idx="2">
+            <a:schemeClr val="accent1"/>
+          </a:effectRef>
+          <a:fontRef idx="minor">
+            <a:schemeClr val="lt1"/>
+          </a:fontRef>
+        </p:style>
+        <p:txBody>
+          <a:bodyPr rtlCol="0" anchor="ctr" lIns="0" rIns="0" tIns="0" bIns="0"/>
+          <a:lstStyle/>
+          <a:p>
+            <a:pPr algn="ctr"/>
+            <a:r>
+              <a:rPr sz="1600" b="1" i="0">
+                <a:solidFill>
+                  <a:srgbClr val="FFFFFF"/>
+                </a:solidFill>
+                <a:latin typeface="Calibri"/>
+              </a:rPr>
+              <a:t>65</a:t>
+            </a:r>
+          </a:p>
+        </p:txBody>
+      </p:sp>
+      <p:sp>
+        <p:nvSpPr>
+          <p:cNvPr id="5" name="TextBox 4"/>
+          <p:cNvSpPr txBox="1"/>
+          <p:nvPr/>
+        </p:nvSpPr>
+        <p:spPr>
+          <a:xfrm>
+            <a:off x="1005840" y="109728"/>
+            <a:ext cx="10728655" cy="777240"/>
+          </a:xfrm>
+          <a:prstGeom prst="rect">
+            <a:avLst/>
+          </a:prstGeom>
+          <a:noFill/>
+        </p:spPr>
+        <p:txBody>
+          <a:bodyPr wrap="square" anchor="ctr" lIns="0" rIns="0" tIns="0" bIns="0">
+            <a:spAutoFit/>
+          </a:bodyPr>
+          <a:lstStyle/>
+          <a:p>
+            <a:r>
+              <a:rPr sz="1100" b="1" i="0">
+                <a:solidFill>
+                  <a:srgbClr val="99F6E4"/>
+                </a:solidFill>
+                <a:latin typeface="Calibri"/>
+              </a:rPr>
+              <a:t>ANEXO · CASO 2D PLATFORMER · LO QUE NO SE VE</a:t>
+            </a:r>
+          </a:p>
+          <a:p>
+            <a:r>
+              <a:rPr sz="2600" b="1" i="0">
+                <a:solidFill>
+                  <a:srgbClr val="FFFFFF"/>
+                </a:solidFill>
+                <a:latin typeface="Calibri"/>
+              </a:rPr>
+              <a:t>Antes y después: proyecto</a:t>
+            </a:r>
+          </a:p>
+        </p:txBody>
+      </p:sp>
+      <p:sp>
+        <p:nvSpPr>
+          <p:cNvPr id="6" name="TextBox 5"/>
+          <p:cNvSpPr txBox="1"/>
+          <p:nvPr/>
+        </p:nvSpPr>
+        <p:spPr>
+          <a:xfrm>
+            <a:off x="502920" y="6473952"/>
+            <a:ext cx="11185855" cy="274320"/>
+          </a:xfrm>
+          <a:prstGeom prst="rect">
+            <a:avLst/>
+          </a:prstGeom>
+          <a:noFill/>
+        </p:spPr>
+        <p:txBody>
+          <a:bodyPr wrap="square" anchor="ctr" lIns="0" rIns="0" tIns="0" bIns="0">
+            <a:spAutoFit/>
+          </a:bodyPr>
+          <a:lstStyle/>
+          <a:p>
+            <a:r>
+              <a:rPr sz="1000" b="0" i="0">
+                <a:solidFill>
+                  <a:srgbClr val="6B7280"/>
+                </a:solidFill>
+                <a:latin typeface="Calibri"/>
+              </a:rPr>
+              <a:t>Diseño según Plataformas de Juego · Unidad IV · Anexo · Anexo: Android en Unity 6</a:t>
+            </a:r>
+          </a:p>
+        </p:txBody>
+      </p:sp>
+      <p:sp>
+        <p:nvSpPr>
+          <p:cNvPr id="7" name="TextBox 6"/>
+          <p:cNvSpPr txBox="1"/>
+          <p:nvPr/>
+        </p:nvSpPr>
+        <p:spPr>
+          <a:xfrm>
+            <a:off x="10774375" y="6473952"/>
+            <a:ext cx="914400" cy="274320"/>
+          </a:xfrm>
+          <a:prstGeom prst="rect">
+            <a:avLst/>
+          </a:prstGeom>
+          <a:noFill/>
+        </p:spPr>
+        <p:txBody>
+          <a:bodyPr wrap="square" anchor="ctr" lIns="0" rIns="0" tIns="0" bIns="0">
+            <a:spAutoFit/>
+          </a:bodyPr>
+          <a:lstStyle/>
+          <a:p>
+            <a:pPr algn="r"/>
+            <a:r>
+              <a:rPr sz="1000" b="0" i="0">
+                <a:solidFill>
+                  <a:srgbClr val="6B7280"/>
+                </a:solidFill>
+                <a:latin typeface="Calibri"/>
+              </a:rPr>
+              <a:t>65/65</a:t>
+            </a:r>
+          </a:p>
+        </p:txBody>
+      </p:sp>
+      <p:sp>
+        <p:nvSpPr>
+          <p:cNvPr id="8" name="TextBox 7"/>
+          <p:cNvSpPr txBox="1"/>
+          <p:nvPr/>
+        </p:nvSpPr>
+        <p:spPr>
+          <a:xfrm>
+            <a:off x="502920" y="6126480"/>
+            <a:ext cx="11185855" cy="292608"/>
+          </a:xfrm>
+          <a:prstGeom prst="rect">
+            <a:avLst/>
+          </a:prstGeom>
+          <a:noFill/>
+        </p:spPr>
+        <p:txBody>
+          <a:bodyPr wrap="square" anchor="ctr" lIns="0" rIns="0" tIns="0" bIns="0">
+            <a:spAutoFit/>
+          </a:bodyPr>
+          <a:lstStyle/>
+          <a:p>
+            <a:r>
+              <a:rPr sz="1000" b="1" i="0">
+                <a:solidFill>
+                  <a:srgbClr val="6B7280"/>
+                </a:solidFill>
+                <a:latin typeface="Calibri"/>
+              </a:rPr>
+              <a:t>Fuente: </a:t>
+            </a:r>
+            <a:r>
+              <a:rPr sz="1000" b="0" i="0">
+                <a:solidFill>
+                  <a:srgbClr val="6B7280"/>
+                </a:solidFill>
+                <a:latin typeface="Calibri"/>
+              </a:rPr>
+              <a:t>laboratorio-adaptacion/PORTEO-PLATFORMER.md; logs y XML en laboratorio-adaptacion/evidencia/platformer-v2-*</a:t>
+            </a:r>
+          </a:p>
+        </p:txBody>
+      </p:sp>
+      <p:sp>
+        <p:nvSpPr>
+          <p:cNvPr id="9" name="Rectangle 8"/>
+          <p:cNvSpPr/>
+          <p:nvPr/>
+        </p:nvSpPr>
+        <p:spPr>
+          <a:xfrm>
+            <a:off x="502920" y="5577840"/>
+            <a:ext cx="109728" cy="457200"/>
+          </a:xfrm>
+          <a:prstGeom prst="rect">
+            <a:avLst/>
+          </a:prstGeom>
+          <a:solidFill>
+            <a:srgbClr val="D97706"/>
+          </a:solidFill>
+          <a:ln>
+            <a:noFill/>
+          </a:ln>
+          <a:effectLst/>
+        </p:spPr>
+        <p:style>
+          <a:lnRef idx="1">
+            <a:schemeClr val="accent1"/>
+          </a:lnRef>
+          <a:fillRef idx="3">
+            <a:schemeClr val="accent1"/>
+          </a:fillRef>
+          <a:effectRef idx="2">
+            <a:schemeClr val="accent1"/>
+          </a:effectRef>
+          <a:fontRef idx="minor">
+            <a:schemeClr val="lt1"/>
+          </a:fontRef>
+        </p:style>
+        <p:txBody>
+          <a:bodyPr rtlCol="0" anchor="ctr"/>
+          <a:lstStyle/>
+          <a:p>
+            <a:pPr algn="ctr"/>
+          </a:p>
+        </p:txBody>
+      </p:sp>
+      <p:sp>
+        <p:nvSpPr>
+          <p:cNvPr id="10" name="Rectangle 9"/>
+          <p:cNvSpPr/>
+          <p:nvPr/>
+        </p:nvSpPr>
+        <p:spPr>
+          <a:xfrm>
+            <a:off x="612648" y="5577840"/>
+            <a:ext cx="11076127" cy="457200"/>
+          </a:xfrm>
+          <a:prstGeom prst="rect">
+            <a:avLst/>
+          </a:prstGeom>
+          <a:solidFill>
+            <a:srgbClr val="F3F4F6"/>
+          </a:solidFill>
+          <a:ln>
+            <a:noFill/>
+          </a:ln>
+          <a:effectLst/>
+        </p:spPr>
+        <p:style>
+          <a:lnRef idx="1">
+            <a:schemeClr val="accent1"/>
+          </a:lnRef>
+          <a:fillRef idx="3">
+            <a:schemeClr val="accent1"/>
+          </a:fillRef>
+          <a:effectRef idx="2">
+            <a:schemeClr val="accent1"/>
+          </a:effectRef>
+          <a:fontRef idx="minor">
+            <a:schemeClr val="lt1"/>
+          </a:fontRef>
+        </p:style>
+        <p:txBody>
+          <a:bodyPr rtlCol="0" anchor="ctr" wrap="square" lIns="137160"/>
+          <a:lstStyle/>
+          <a:p>
+            <a:pPr algn="l"/>
+            <a:r>
+              <a:rPr sz="1300" b="1" i="0">
+                <a:solidFill>
+                  <a:srgbClr val="D97706"/>
+                </a:solidFill>
+                <a:latin typeface="Calibri"/>
+              </a:rPr>
+              <a:t>PREGUNTA  </a:t>
+            </a:r>
+            <a:r>
+              <a:rPr sz="1400" b="0" i="0">
+                <a:solidFill>
+                  <a:srgbClr val="1F2937"/>
+                </a:solidFill>
+                <a:latin typeface="Calibri"/>
+              </a:rPr>
+              <a:t>¿Por qué fallan 2 tests si el porteo está bien?</a:t>
+            </a:r>
+          </a:p>
+        </p:txBody>
+      </p:sp>
+      <p:graphicFrame>
+        <p:nvGraphicFramePr>
+          <p:cNvPr id="11" name="Table 10"/>
+          <p:cNvGraphicFramePr>
+            <a:graphicFrameLocks noGrp="1"/>
+          </p:cNvGraphicFramePr>
+          <p:nvPr/>
+        </p:nvGraphicFramePr>
+        <p:xfrm>
+          <a:off x="502920" y="1234440"/>
+          <a:ext cx="11185854" cy="3968496"/>
+        </p:xfrm>
+        <a:graphic>
+          <a:graphicData uri="http://schemas.openxmlformats.org/drawingml/2006/table">
+            <a:tbl>
+              <a:tblPr firstRow="1" bandRow="1">
+                <a:tableStyleId>{5C22544A-7EE6-4342-B048-85BDC9FD1C3A}</a:tableStyleId>
+              </a:tblPr>
+              <a:tblGrid>
+                <a:gridCol w="2684605"/>
+                <a:gridCol w="4474342"/>
+                <a:gridCol w="4026907"/>
+              </a:tblGrid>
+              <a:tr h="566928">
+                <a:tc>
+                  <a:txBody>
+                    <a:bodyPr wrap="square"/>
+                    <a:lstStyle/>
+                    <a:p>
+                      <a:r>
+                        <a:rPr sz="1200" b="1" i="0">
+                          <a:solidFill>
+                            <a:srgbClr val="FFFFFF"/>
+                          </a:solidFill>
+                          <a:latin typeface="Calibri"/>
+                        </a:rPr>
+                        <a:t>Aspecto</a:t>
+                      </a:r>
+                    </a:p>
+                  </a:txBody>
+                  <a:tcPr marL="73152" marR="73152" marT="36576" marB="36576" anchor="ctr">
+                    <a:solidFill>
+                      <a:srgbClr val="0D9488"/>
+                    </a:solidFill>
+                  </a:tcPr>
+                </a:tc>
+                <a:tc>
+                  <a:txBody>
+                    <a:bodyPr wrap="square"/>
+                    <a:lstStyle/>
+                    <a:p>
+                      <a:r>
+                        <a:rPr sz="1200" b="1" i="0">
+                          <a:solidFill>
+                            <a:srgbClr val="FFFFFF"/>
+                          </a:solidFill>
+                          <a:latin typeface="Calibri"/>
+                        </a:rPr>
+                        <a:t>Antes (original)</a:t>
+                      </a:r>
+                    </a:p>
+                  </a:txBody>
+                  <a:tcPr marL="73152" marR="73152" marT="36576" marB="36576" anchor="ctr">
+                    <a:solidFill>
+                      <a:srgbClr val="0D9488"/>
+                    </a:solidFill>
+                  </a:tcPr>
+                </a:tc>
+                <a:tc>
+                  <a:txBody>
+                    <a:bodyPr wrap="square"/>
+                    <a:lstStyle/>
+                    <a:p>
+                      <a:r>
+                        <a:rPr sz="1200" b="1" i="0">
+                          <a:solidFill>
+                            <a:srgbClr val="FFFFFF"/>
+                          </a:solidFill>
+                          <a:latin typeface="Calibri"/>
+                        </a:rPr>
+                        <a:t>Después (versión 2)</a:t>
+                      </a:r>
+                    </a:p>
+                  </a:txBody>
+                  <a:tcPr marL="73152" marR="73152" marT="36576" marB="36576" anchor="ctr">
+                    <a:solidFill>
+                      <a:srgbClr val="0D9488"/>
+                    </a:solidFill>
+                  </a:tcPr>
+                </a:tc>
+              </a:tr>
+              <a:tr h="566928">
+                <a:tc>
+                  <a:txBody>
+                    <a:bodyPr wrap="square"/>
+                    <a:lstStyle/>
+                    <a:p>
+                      <a:r>
+                        <a:rPr sz="1200" b="0" i="0">
+                          <a:solidFill>
+                            <a:srgbClr val="1F2937"/>
+                          </a:solidFill>
+                          <a:latin typeface="Calibri"/>
+                        </a:rPr>
+                        <a:t>Sistema de entrada</a:t>
+                      </a:r>
+                    </a:p>
+                  </a:txBody>
+                  <a:tcPr marL="73152" marR="73152" marT="36576" marB="36576" anchor="ctr">
+                    <a:solidFill>
+                      <a:srgbClr val="FFFFFF"/>
+                    </a:solidFill>
+                  </a:tcPr>
+                </a:tc>
+                <a:tc>
+                  <a:txBody>
+                    <a:bodyPr wrap="square"/>
+                    <a:lstStyle/>
+                    <a:p>
+                      <a:r>
+                        <a:rPr sz="1200" b="0" i="0">
+                          <a:solidFill>
+                            <a:srgbClr val="1F2937"/>
+                          </a:solidFill>
+                          <a:latin typeface="Calibri"/>
+                        </a:rPr>
+                        <a:t>Input Manager</a:t>
+                      </a:r>
+                    </a:p>
+                  </a:txBody>
+                  <a:tcPr marL="73152" marR="73152" marT="36576" marB="36576" anchor="ctr">
+                    <a:solidFill>
+                      <a:srgbClr val="FFFFFF"/>
+                    </a:solidFill>
+                  </a:tcPr>
+                </a:tc>
+                <a:tc>
+                  <a:txBody>
+                    <a:bodyPr wrap="square"/>
+                    <a:lstStyle/>
+                    <a:p>
+                      <a:r>
+                        <a:rPr sz="1200" b="0" i="0">
+                          <a:solidFill>
+                            <a:srgbClr val="1F2937"/>
+                          </a:solidFill>
+                          <a:latin typeface="Calibri"/>
+                        </a:rPr>
+                        <a:t>Input System 1.19 (solo "New")</a:t>
+                      </a:r>
+                    </a:p>
+                  </a:txBody>
+                  <a:tcPr marL="73152" marR="73152" marT="36576" marB="36576" anchor="ctr">
+                    <a:solidFill>
+                      <a:srgbClr val="FFFFFF"/>
+                    </a:solidFill>
+                  </a:tcPr>
+                </a:tc>
+              </a:tr>
+              <a:tr h="566928">
+                <a:tc>
+                  <a:txBody>
+                    <a:bodyPr wrap="square"/>
+                    <a:lstStyle/>
+                    <a:p>
+                      <a:r>
+                        <a:rPr sz="1200" b="0" i="0">
+                          <a:solidFill>
+                            <a:srgbClr val="1F2937"/>
+                          </a:solidFill>
+                          <a:latin typeface="Calibri"/>
+                        </a:rPr>
+                        <a:t>Quién lee el input</a:t>
+                      </a:r>
+                    </a:p>
+                  </a:txBody>
+                  <a:tcPr marL="73152" marR="73152" marT="36576" marB="36576" anchor="ctr">
+                    <a:solidFill>
+                      <a:srgbClr val="E6F4F2"/>
+                    </a:solidFill>
+                  </a:tcPr>
+                </a:tc>
+                <a:tc>
+                  <a:txBody>
+                    <a:bodyPr wrap="square"/>
+                    <a:lstStyle/>
+                    <a:p>
+                      <a:r>
+                        <a:rPr sz="1200" b="0" i="0">
+                          <a:solidFill>
+                            <a:srgbClr val="1F2937"/>
+                          </a:solidFill>
+                          <a:latin typeface="Calibri"/>
+                        </a:rPr>
+                        <a:t>PlayerController</a:t>
+                      </a:r>
+                    </a:p>
+                  </a:txBody>
+                  <a:tcPr marL="73152" marR="73152" marT="36576" marB="36576" anchor="ctr">
+                    <a:solidFill>
+                      <a:srgbClr val="E6F4F2"/>
+                    </a:solidFill>
+                  </a:tcPr>
+                </a:tc>
+                <a:tc>
+                  <a:txBody>
+                    <a:bodyPr wrap="square"/>
+                    <a:lstStyle/>
+                    <a:p>
+                      <a:r>
+                        <a:rPr sz="1200" b="0" i="0">
+                          <a:solidFill>
+                            <a:srgbClr val="1F2937"/>
+                          </a:solidFill>
+                          <a:latin typeface="Calibri"/>
+                        </a:rPr>
+                        <a:t>Adaptador → SetIntent</a:t>
+                      </a:r>
+                    </a:p>
+                  </a:txBody>
+                  <a:tcPr marL="73152" marR="73152" marT="36576" marB="36576" anchor="ctr">
+                    <a:solidFill>
+                      <a:srgbClr val="E6F4F2"/>
+                    </a:solidFill>
+                  </a:tcPr>
+                </a:tc>
+              </a:tr>
+              <a:tr h="566928">
+                <a:tc>
+                  <a:txBody>
+                    <a:bodyPr wrap="square"/>
+                    <a:lstStyle/>
+                    <a:p>
+                      <a:r>
+                        <a:rPr sz="1200" b="0" i="0">
+                          <a:solidFill>
+                            <a:srgbClr val="1F2937"/>
+                          </a:solidFill>
+                          <a:latin typeface="Calibri"/>
+                        </a:rPr>
+                        <a:t>Módulo de UI</a:t>
+                      </a:r>
+                    </a:p>
+                  </a:txBody>
+                  <a:tcPr marL="73152" marR="73152" marT="36576" marB="36576" anchor="ctr">
+                    <a:solidFill>
+                      <a:srgbClr val="FFFFFF"/>
+                    </a:solidFill>
+                  </a:tcPr>
+                </a:tc>
+                <a:tc>
+                  <a:txBody>
+                    <a:bodyPr wrap="square"/>
+                    <a:lstStyle/>
+                    <a:p>
+                      <a:r>
+                        <a:rPr sz="1200" b="0" i="0">
+                          <a:solidFill>
+                            <a:srgbClr val="1F2937"/>
+                          </a:solidFill>
+                          <a:latin typeface="Calibri"/>
+                        </a:rPr>
+                        <a:t>StandaloneInputModule</a:t>
+                      </a:r>
+                    </a:p>
+                  </a:txBody>
+                  <a:tcPr marL="73152" marR="73152" marT="36576" marB="36576" anchor="ctr">
+                    <a:solidFill>
+                      <a:srgbClr val="FFFFFF"/>
+                    </a:solidFill>
+                  </a:tcPr>
+                </a:tc>
+                <a:tc>
+                  <a:txBody>
+                    <a:bodyPr wrap="square"/>
+                    <a:lstStyle/>
+                    <a:p>
+                      <a:r>
+                        <a:rPr sz="1200" b="0" i="0">
+                          <a:solidFill>
+                            <a:srgbClr val="1F2937"/>
+                          </a:solidFill>
+                          <a:latin typeface="Calibri"/>
+                        </a:rPr>
+                        <a:t>InputSystemUIInputModule</a:t>
+                      </a:r>
+                    </a:p>
+                  </a:txBody>
+                  <a:tcPr marL="73152" marR="73152" marT="36576" marB="36576" anchor="ctr">
+                    <a:solidFill>
+                      <a:srgbClr val="FFFFFF"/>
+                    </a:solidFill>
+                  </a:tcPr>
+                </a:tc>
+              </a:tr>
+              <a:tr h="566928">
+                <a:tc>
+                  <a:txBody>
+                    <a:bodyPr wrap="square"/>
+                    <a:lstStyle/>
+                    <a:p>
+                      <a:r>
+                        <a:rPr sz="1200" b="0" i="0">
+                          <a:solidFill>
+                            <a:srgbClr val="1F2937"/>
+                          </a:solidFill>
+                          <a:latin typeface="Calibri"/>
+                        </a:rPr>
+                        <a:t>Error "isGrounded"</a:t>
+                      </a:r>
+                    </a:p>
+                  </a:txBody>
+                  <a:tcPr marL="73152" marR="73152" marT="36576" marB="36576" anchor="ctr">
+                    <a:solidFill>
+                      <a:srgbClr val="E6F4F2"/>
+                    </a:solidFill>
+                  </a:tcPr>
+                </a:tc>
+                <a:tc>
+                  <a:txBody>
+                    <a:bodyPr wrap="square"/>
+                    <a:lstStyle/>
+                    <a:p>
+                      <a:r>
+                        <a:rPr sz="1200" b="0" i="0">
+                          <a:solidFill>
+                            <a:srgbClr val="1F2937"/>
+                          </a:solidFill>
+                          <a:latin typeface="Calibri"/>
+                        </a:rPr>
+                        <a:t>2447 por sesión</a:t>
+                      </a:r>
+                    </a:p>
+                  </a:txBody>
+                  <a:tcPr marL="73152" marR="73152" marT="36576" marB="36576" anchor="ctr">
+                    <a:solidFill>
+                      <a:srgbClr val="E6F4F2"/>
+                    </a:solidFill>
+                  </a:tcPr>
+                </a:tc>
+                <a:tc>
+                  <a:txBody>
+                    <a:bodyPr wrap="square"/>
+                    <a:lstStyle/>
+                    <a:p>
+                      <a:r>
+                        <a:rPr sz="1200" b="0" i="0">
+                          <a:solidFill>
+                            <a:srgbClr val="1F2937"/>
+                          </a:solidFill>
+                          <a:latin typeface="Calibri"/>
+                        </a:rPr>
+                        <a:t>0</a:t>
+                      </a:r>
+                    </a:p>
+                  </a:txBody>
+                  <a:tcPr marL="73152" marR="73152" marT="36576" marB="36576" anchor="ctr">
+                    <a:solidFill>
+                      <a:srgbClr val="E6F4F2"/>
+                    </a:solidFill>
+                  </a:tcPr>
+                </a:tc>
+              </a:tr>
+              <a:tr h="566928">
+                <a:tc>
+                  <a:txBody>
+                    <a:bodyPr wrap="square"/>
+                    <a:lstStyle/>
+                    <a:p>
+                      <a:r>
+                        <a:rPr sz="1200" b="0" i="0">
+                          <a:solidFill>
+                            <a:srgbClr val="1F2937"/>
+                          </a:solidFill>
+                          <a:latin typeface="Calibri"/>
+                        </a:rPr>
+                        <a:t>Build Android</a:t>
+                      </a:r>
+                    </a:p>
+                  </a:txBody>
+                  <a:tcPr marL="73152" marR="73152" marT="36576" marB="36576" anchor="ctr">
+                    <a:solidFill>
+                      <a:srgbClr val="FFFFFF"/>
+                    </a:solidFill>
+                  </a:tcPr>
+                </a:tc>
+                <a:tc>
+                  <a:txBody>
+                    <a:bodyPr wrap="square"/>
+                    <a:lstStyle/>
+                    <a:p>
+                      <a:r>
+                        <a:rPr sz="1200" b="0" i="0">
+                          <a:solidFill>
+                            <a:srgbClr val="1F2937"/>
+                          </a:solidFill>
+                          <a:latin typeface="Calibri"/>
+                        </a:rPr>
+                        <a:t>Falla (URP en modo compatibilidad)</a:t>
+                      </a:r>
+                    </a:p>
+                  </a:txBody>
+                  <a:tcPr marL="73152" marR="73152" marT="36576" marB="36576" anchor="ctr">
+                    <a:solidFill>
+                      <a:srgbClr val="FFFFFF"/>
+                    </a:solidFill>
+                  </a:tcPr>
+                </a:tc>
+                <a:tc>
+                  <a:txBody>
+                    <a:bodyPr wrap="square"/>
+                    <a:lstStyle/>
+                    <a:p>
+                      <a:r>
+                        <a:rPr sz="1200" b="0" i="0">
+                          <a:solidFill>
+                            <a:srgbClr val="1F2937"/>
+                          </a:solidFill>
+                          <a:latin typeface="Calibri"/>
+                        </a:rPr>
+                        <a:t>APK de 35,9 MB</a:t>
+                      </a:r>
+                    </a:p>
+                  </a:txBody>
+                  <a:tcPr marL="73152" marR="73152" marT="36576" marB="36576" anchor="ctr">
+                    <a:solidFill>
+                      <a:srgbClr val="FFFFFF"/>
+                    </a:solidFill>
+                  </a:tcPr>
+                </a:tc>
+              </a:tr>
+              <a:tr h="566928">
+                <a:tc>
+                  <a:txBody>
+                    <a:bodyPr wrap="square"/>
+                    <a:lstStyle/>
+                    <a:p>
+                      <a:r>
+                        <a:rPr sz="1200" b="0" i="0">
+                          <a:solidFill>
+                            <a:srgbClr val="1F2937"/>
+                          </a:solidFill>
+                          <a:latin typeface="Calibri"/>
+                        </a:rPr>
+                        <a:t>Tests automáticos</a:t>
+                      </a:r>
+                    </a:p>
+                  </a:txBody>
+                  <a:tcPr marL="73152" marR="73152" marT="36576" marB="36576" anchor="ctr">
+                    <a:solidFill>
+                      <a:srgbClr val="E6F4F2"/>
+                    </a:solidFill>
+                  </a:tcPr>
+                </a:tc>
+                <a:tc>
+                  <a:txBody>
+                    <a:bodyPr wrap="square"/>
+                    <a:lstStyle/>
+                    <a:p>
+                      <a:r>
+                        <a:rPr sz="1200" b="0" i="0">
+                          <a:solidFill>
+                            <a:srgbClr val="1F2937"/>
+                          </a:solidFill>
+                          <a:latin typeface="Calibri"/>
+                        </a:rPr>
+                        <a:t>Ninguno</a:t>
+                      </a:r>
+                    </a:p>
+                  </a:txBody>
+                  <a:tcPr marL="73152" marR="73152" marT="36576" marB="36576" anchor="ctr">
+                    <a:solidFill>
+                      <a:srgbClr val="E6F4F2"/>
+                    </a:solidFill>
+                  </a:tcPr>
+                </a:tc>
+                <a:tc>
+                  <a:txBody>
+                    <a:bodyPr wrap="square"/>
+                    <a:lstStyle/>
+                    <a:p>
+                      <a:r>
+                        <a:rPr sz="1200" b="0" i="0">
+                          <a:solidFill>
+                            <a:srgbClr val="1F2937"/>
+                          </a:solidFill>
+                          <a:latin typeface="Calibri"/>
+                        </a:rPr>
+                        <a:t>16: pasan 14, fallan 2</a:t>
+                      </a:r>
+                    </a:p>
+                  </a:txBody>
+                  <a:tcPr marL="73152" marR="73152" marT="36576" marB="36576" anchor="ctr">
+                    <a:solidFill>
+                      <a:srgbClr val="E6F4F2"/>
+                    </a:solidFill>
+                  </a:tcPr>
+                </a:tc>
+              </a:tr>
+            </a:tbl>
+          </a:graphicData>
+        </a:graphic>
+      </p:graphicFrame>
+    </p:spTree>
+  </p:cSld>
+  <p:clrMapOvr>
+    <a:masterClrMapping/>
+  </p:clrMapOvr>
+</p:sld>
+</file>
+
 <file path=ppt/slides/slide7.xml><?xml version="1.0" encoding="utf-8"?>
 <p:sld xmlns:a="http://schemas.openxmlformats.org/drawingml/2006/main" xmlns:p="http://schemas.openxmlformats.org/presentationml/2006/main" xmlns:r="http://schemas.openxmlformats.org/officeDocument/2006/relationships">
   <p:cSld>
@@ -51933,7 +54782,7 @@
                 </a:solidFill>
                 <a:latin typeface="Calibri"/>
               </a:rPr>
-              <a:t>7/63</a:t>
+              <a:t>7/65</a:t>
             </a:r>
           </a:p>
         </p:txBody>
@@ -51990,6 +54839,122 @@
         <p:spPr>
           <a:xfrm>
             <a:off x="502920" y="5577840"/>
+            <a:ext cx="109728" cy="457200"/>
+          </a:xfrm>
+          <a:prstGeom prst="rect">
+            <a:avLst/>
+          </a:prstGeom>
+          <a:solidFill>
+            <a:srgbClr val="DC2626"/>
+          </a:solidFill>
+          <a:ln>
+            <a:noFill/>
+          </a:ln>
+          <a:effectLst/>
+        </p:spPr>
+        <p:style>
+          <a:lnRef idx="1">
+            <a:schemeClr val="accent1"/>
+          </a:lnRef>
+          <a:fillRef idx="3">
+            <a:schemeClr val="accent1"/>
+          </a:fillRef>
+          <a:effectRef idx="2">
+            <a:schemeClr val="accent1"/>
+          </a:effectRef>
+          <a:fontRef idx="minor">
+            <a:schemeClr val="lt1"/>
+          </a:fontRef>
+        </p:style>
+        <p:txBody>
+          <a:bodyPr rtlCol="0" anchor="ctr"/>
+          <a:lstStyle/>
+          <a:p>
+            <a:pPr algn="ctr"/>
+          </a:p>
+        </p:txBody>
+      </p:sp>
+      <p:sp>
+        <p:nvSpPr>
+          <p:cNvPr id="10" name="Rectangle 9"/>
+          <p:cNvSpPr/>
+          <p:nvPr/>
+        </p:nvSpPr>
+        <p:spPr>
+          <a:xfrm>
+            <a:off x="612648" y="5577840"/>
+            <a:ext cx="11076127" cy="457200"/>
+          </a:xfrm>
+          <a:prstGeom prst="rect">
+            <a:avLst/>
+          </a:prstGeom>
+          <a:solidFill>
+            <a:srgbClr val="F3F4F6"/>
+          </a:solidFill>
+          <a:ln>
+            <a:noFill/>
+          </a:ln>
+          <a:effectLst/>
+        </p:spPr>
+        <p:style>
+          <a:lnRef idx="1">
+            <a:schemeClr val="accent1"/>
+          </a:lnRef>
+          <a:fillRef idx="3">
+            <a:schemeClr val="accent1"/>
+          </a:fillRef>
+          <a:effectRef idx="2">
+            <a:schemeClr val="accent1"/>
+          </a:effectRef>
+          <a:fontRef idx="minor">
+            <a:schemeClr val="lt1"/>
+          </a:fontRef>
+        </p:style>
+        <p:txBody>
+          <a:bodyPr rtlCol="0" anchor="ctr" wrap="square" lIns="137160"/>
+          <a:lstStyle/>
+          <a:p>
+            <a:pPr algn="l"/>
+            <a:r>
+              <a:rPr sz="1300" b="1" i="0">
+                <a:solidFill>
+                  <a:srgbClr val="DC2626"/>
+                </a:solidFill>
+                <a:latin typeface="Calibri"/>
+              </a:rPr>
+              <a:t>VIDEO  </a:t>
+            </a:r>
+            <a:r>
+              <a:rPr sz="1400" b="0" i="0">
+                <a:solidFill>
+                  <a:srgbClr val="1F2937"/>
+                </a:solidFill>
+                <a:latin typeface="Calibri"/>
+              </a:rPr>
+              <a:t>Consulta: </a:t>
+            </a:r>
+            <a:r>
+              <a:rPr sz="1400" b="1" i="0" u="sng">
+                <a:solidFill>
+                  <a:srgbClr val="DC2626"/>
+                </a:solidFill>
+                <a:latin typeface="Calibri"/>
+                <a:hlinkClick r:id="rId2"/>
+              </a:rPr>
+              <a:t>Academia Play, Historia de los videojuegos 1972–1983 (7 min)</a:t>
+            </a:r>
+          </a:p>
+        </p:txBody>
+      </p:sp>
+      <p:sp>
+        <p:nvSpPr>
+          <p:cNvPr id="11" name="Rectangle 10"/>
+          <p:cNvSpPr/>
+          <p:nvPr/>
+        </p:nvSpPr>
+        <p:spPr>
+          <a:xfrm>
+            <a:off x="502920" y="5029200"/>
             <a:ext cx="109728" cy="457200"/>
           </a:xfrm>
           <a:prstGeom prst="rect">
@@ -52027,13 +54992,13 @@
       </p:sp>
       <p:sp>
         <p:nvSpPr>
-          <p:cNvPr id="10" name="Rectangle 9"/>
+          <p:cNvPr id="12" name="Rectangle 11"/>
           <p:cNvSpPr/>
           <p:nvPr/>
         </p:nvSpPr>
         <p:spPr>
           <a:xfrm>
-            <a:off x="612648" y="5577840"/>
+            <a:off x="612648" y="5029200"/>
             <a:ext cx="11076127" cy="457200"/>
           </a:xfrm>
           <a:prstGeom prst="rect">
@@ -52089,13 +55054,13 @@
       </p:sp>
       <p:sp>
         <p:nvSpPr>
-          <p:cNvPr id="11" name="Rectangle 10"/>
+          <p:cNvPr id="13" name="Rectangle 12"/>
           <p:cNvSpPr/>
           <p:nvPr/>
         </p:nvSpPr>
         <p:spPr>
           <a:xfrm>
-            <a:off x="1325880" y="3181350"/>
+            <a:off x="1325880" y="2907030"/>
             <a:ext cx="9539935" cy="38100"/>
           </a:xfrm>
           <a:prstGeom prst="rect">
@@ -52133,13 +55098,13 @@
       </p:sp>
       <p:sp>
         <p:nvSpPr>
-          <p:cNvPr id="12" name="Rectangle 11"/>
+          <p:cNvPr id="14" name="Rectangle 13"/>
           <p:cNvSpPr/>
           <p:nvPr/>
         </p:nvSpPr>
         <p:spPr>
           <a:xfrm>
-            <a:off x="1499235" y="2880360"/>
+            <a:off x="1499235" y="2606040"/>
             <a:ext cx="19050" cy="320040"/>
           </a:xfrm>
           <a:prstGeom prst="rect">
@@ -52177,13 +55142,13 @@
       </p:sp>
       <p:sp>
         <p:nvSpPr>
-          <p:cNvPr id="13" name="Oval 12"/>
+          <p:cNvPr id="15" name="Oval 14"/>
           <p:cNvSpPr/>
           <p:nvPr/>
         </p:nvSpPr>
         <p:spPr>
           <a:xfrm>
-            <a:off x="1417320" y="3108960"/>
+            <a:off x="1417320" y="2834640"/>
             <a:ext cx="182880" cy="182880"/>
           </a:xfrm>
           <a:prstGeom prst="ellipse">
@@ -52221,13 +55186,13 @@
       </p:sp>
       <p:sp>
         <p:nvSpPr>
-          <p:cNvPr id="14" name="Rounded Rectangle 13"/>
+          <p:cNvPr id="16" name="Rounded Rectangle 15"/>
           <p:cNvSpPr/>
           <p:nvPr/>
         </p:nvSpPr>
         <p:spPr>
           <a:xfrm>
-            <a:off x="502920" y="2103120"/>
+            <a:off x="502920" y="1828800"/>
             <a:ext cx="2011680" cy="777240"/>
           </a:xfrm>
           <a:prstGeom prst="roundRect">
@@ -52297,13 +55262,13 @@
       </p:sp>
       <p:sp>
         <p:nvSpPr>
-          <p:cNvPr id="15" name="Rectangle 14"/>
+          <p:cNvPr id="17" name="Rectangle 16"/>
           <p:cNvSpPr/>
           <p:nvPr/>
         </p:nvSpPr>
         <p:spPr>
           <a:xfrm>
-            <a:off x="3028264" y="3200400"/>
+            <a:off x="3028264" y="2926080"/>
             <a:ext cx="19050" cy="320040"/>
           </a:xfrm>
           <a:prstGeom prst="rect">
@@ -52341,13 +55306,13 @@
       </p:sp>
       <p:sp>
         <p:nvSpPr>
-          <p:cNvPr id="16" name="Oval 15"/>
+          <p:cNvPr id="18" name="Oval 17"/>
           <p:cNvSpPr/>
           <p:nvPr/>
         </p:nvSpPr>
         <p:spPr>
           <a:xfrm>
-            <a:off x="2946349" y="3108960"/>
+            <a:off x="2946349" y="2834640"/>
             <a:ext cx="182880" cy="182880"/>
           </a:xfrm>
           <a:prstGeom prst="ellipse">
@@ -52385,13 +55350,13 @@
       </p:sp>
       <p:sp>
         <p:nvSpPr>
-          <p:cNvPr id="17" name="Rounded Rectangle 16"/>
+          <p:cNvPr id="19" name="Rounded Rectangle 18"/>
           <p:cNvSpPr/>
           <p:nvPr/>
         </p:nvSpPr>
         <p:spPr>
           <a:xfrm>
-            <a:off x="2031949" y="3520440"/>
+            <a:off x="2031949" y="3246120"/>
             <a:ext cx="2011680" cy="777240"/>
           </a:xfrm>
           <a:prstGeom prst="roundRect">
@@ -52461,13 +55426,13 @@
       </p:sp>
       <p:sp>
         <p:nvSpPr>
-          <p:cNvPr id="18" name="Rectangle 17"/>
+          <p:cNvPr id="20" name="Rectangle 19"/>
           <p:cNvSpPr/>
           <p:nvPr/>
         </p:nvSpPr>
         <p:spPr>
           <a:xfrm>
-            <a:off x="4557293" y="2880360"/>
+            <a:off x="4557293" y="2606040"/>
             <a:ext cx="19050" cy="320040"/>
           </a:xfrm>
           <a:prstGeom prst="rect">
@@ -52505,13 +55470,13 @@
       </p:sp>
       <p:sp>
         <p:nvSpPr>
-          <p:cNvPr id="19" name="Oval 18"/>
+          <p:cNvPr id="21" name="Oval 20"/>
           <p:cNvSpPr/>
           <p:nvPr/>
         </p:nvSpPr>
         <p:spPr>
           <a:xfrm>
-            <a:off x="4475378" y="3108960"/>
+            <a:off x="4475378" y="2834640"/>
             <a:ext cx="182880" cy="182880"/>
           </a:xfrm>
           <a:prstGeom prst="ellipse">
@@ -52549,13 +55514,13 @@
       </p:sp>
       <p:sp>
         <p:nvSpPr>
-          <p:cNvPr id="20" name="Rounded Rectangle 19"/>
+          <p:cNvPr id="22" name="Rounded Rectangle 21"/>
           <p:cNvSpPr/>
           <p:nvPr/>
         </p:nvSpPr>
         <p:spPr>
           <a:xfrm>
-            <a:off x="3560978" y="2103120"/>
+            <a:off x="3560978" y="1828800"/>
             <a:ext cx="2011680" cy="777240"/>
           </a:xfrm>
           <a:prstGeom prst="roundRect">
@@ -52625,13 +55590,13 @@
       </p:sp>
       <p:sp>
         <p:nvSpPr>
-          <p:cNvPr id="21" name="Rectangle 20"/>
+          <p:cNvPr id="23" name="Rectangle 22"/>
           <p:cNvSpPr/>
           <p:nvPr/>
         </p:nvSpPr>
         <p:spPr>
           <a:xfrm>
-            <a:off x="6086322" y="3200400"/>
+            <a:off x="6086322" y="2926080"/>
             <a:ext cx="19050" cy="320040"/>
           </a:xfrm>
           <a:prstGeom prst="rect">
@@ -52669,13 +55634,13 @@
       </p:sp>
       <p:sp>
         <p:nvSpPr>
-          <p:cNvPr id="22" name="Oval 21"/>
+          <p:cNvPr id="24" name="Oval 23"/>
           <p:cNvSpPr/>
           <p:nvPr/>
         </p:nvSpPr>
         <p:spPr>
           <a:xfrm>
-            <a:off x="6004407" y="3108960"/>
+            <a:off x="6004407" y="2834640"/>
             <a:ext cx="182880" cy="182880"/>
           </a:xfrm>
           <a:prstGeom prst="ellipse">
@@ -52713,13 +55678,13 @@
       </p:sp>
       <p:sp>
         <p:nvSpPr>
-          <p:cNvPr id="23" name="Rounded Rectangle 22"/>
+          <p:cNvPr id="25" name="Rounded Rectangle 24"/>
           <p:cNvSpPr/>
           <p:nvPr/>
         </p:nvSpPr>
         <p:spPr>
           <a:xfrm>
-            <a:off x="5090007" y="3520440"/>
+            <a:off x="5090007" y="3246120"/>
             <a:ext cx="2011680" cy="777240"/>
           </a:xfrm>
           <a:prstGeom prst="roundRect">
@@ -52789,13 +55754,13 @@
       </p:sp>
       <p:sp>
         <p:nvSpPr>
-          <p:cNvPr id="24" name="Rectangle 23"/>
+          <p:cNvPr id="26" name="Rectangle 25"/>
           <p:cNvSpPr/>
           <p:nvPr/>
         </p:nvSpPr>
         <p:spPr>
           <a:xfrm>
-            <a:off x="7615351" y="2880360"/>
+            <a:off x="7615351" y="2606040"/>
             <a:ext cx="19050" cy="320040"/>
           </a:xfrm>
           <a:prstGeom prst="rect">
@@ -52833,13 +55798,13 @@
       </p:sp>
       <p:sp>
         <p:nvSpPr>
-          <p:cNvPr id="25" name="Oval 24"/>
+          <p:cNvPr id="27" name="Oval 26"/>
           <p:cNvSpPr/>
           <p:nvPr/>
         </p:nvSpPr>
         <p:spPr>
           <a:xfrm>
-            <a:off x="7533436" y="3108960"/>
+            <a:off x="7533436" y="2834640"/>
             <a:ext cx="182880" cy="182880"/>
           </a:xfrm>
           <a:prstGeom prst="ellipse">
@@ -52877,13 +55842,13 @@
       </p:sp>
       <p:sp>
         <p:nvSpPr>
-          <p:cNvPr id="26" name="Rounded Rectangle 25"/>
+          <p:cNvPr id="28" name="Rounded Rectangle 27"/>
           <p:cNvSpPr/>
           <p:nvPr/>
         </p:nvSpPr>
         <p:spPr>
           <a:xfrm>
-            <a:off x="6619036" y="2103120"/>
+            <a:off x="6619036" y="1828800"/>
             <a:ext cx="2011680" cy="777240"/>
           </a:xfrm>
           <a:prstGeom prst="roundRect">
@@ -52953,13 +55918,13 @@
       </p:sp>
       <p:sp>
         <p:nvSpPr>
-          <p:cNvPr id="27" name="Rectangle 26"/>
+          <p:cNvPr id="29" name="Rectangle 28"/>
           <p:cNvSpPr/>
           <p:nvPr/>
         </p:nvSpPr>
         <p:spPr>
           <a:xfrm>
-            <a:off x="9144380" y="3200400"/>
+            <a:off x="9144380" y="2926080"/>
             <a:ext cx="19050" cy="320040"/>
           </a:xfrm>
           <a:prstGeom prst="rect">
@@ -52997,13 +55962,13 @@
       </p:sp>
       <p:sp>
         <p:nvSpPr>
-          <p:cNvPr id="28" name="Oval 27"/>
+          <p:cNvPr id="30" name="Oval 29"/>
           <p:cNvSpPr/>
           <p:nvPr/>
         </p:nvSpPr>
         <p:spPr>
           <a:xfrm>
-            <a:off x="9062465" y="3108960"/>
+            <a:off x="9062465" y="2834640"/>
             <a:ext cx="182880" cy="182880"/>
           </a:xfrm>
           <a:prstGeom prst="ellipse">
@@ -53041,13 +56006,13 @@
       </p:sp>
       <p:sp>
         <p:nvSpPr>
-          <p:cNvPr id="29" name="Rounded Rectangle 28"/>
+          <p:cNvPr id="31" name="Rounded Rectangle 30"/>
           <p:cNvSpPr/>
           <p:nvPr/>
         </p:nvSpPr>
         <p:spPr>
           <a:xfrm>
-            <a:off x="8148065" y="3520440"/>
+            <a:off x="8148065" y="3246120"/>
             <a:ext cx="2011680" cy="777240"/>
           </a:xfrm>
           <a:prstGeom prst="roundRect">
@@ -53117,13 +56082,13 @@
       </p:sp>
       <p:sp>
         <p:nvSpPr>
-          <p:cNvPr id="30" name="Rectangle 29"/>
+          <p:cNvPr id="32" name="Rectangle 31"/>
           <p:cNvSpPr/>
           <p:nvPr/>
         </p:nvSpPr>
         <p:spPr>
           <a:xfrm>
-            <a:off x="10673410" y="2880360"/>
+            <a:off x="10673410" y="2606040"/>
             <a:ext cx="19050" cy="320040"/>
           </a:xfrm>
           <a:prstGeom prst="rect">
@@ -53161,13 +56126,13 @@
       </p:sp>
       <p:sp>
         <p:nvSpPr>
-          <p:cNvPr id="31" name="Oval 30"/>
+          <p:cNvPr id="33" name="Oval 32"/>
           <p:cNvSpPr/>
           <p:nvPr/>
         </p:nvSpPr>
         <p:spPr>
           <a:xfrm>
-            <a:off x="10591495" y="3108960"/>
+            <a:off x="10591495" y="2834640"/>
             <a:ext cx="182880" cy="182880"/>
           </a:xfrm>
           <a:prstGeom prst="ellipse">
@@ -53205,13 +56170,13 @@
       </p:sp>
       <p:sp>
         <p:nvSpPr>
-          <p:cNvPr id="32" name="Rounded Rectangle 31"/>
+          <p:cNvPr id="34" name="Rounded Rectangle 33"/>
           <p:cNvSpPr/>
           <p:nvPr/>
         </p:nvSpPr>
         <p:spPr>
           <a:xfrm>
-            <a:off x="9677095" y="2103120"/>
+            <a:off x="9677095" y="1828800"/>
             <a:ext cx="2011680" cy="777240"/>
           </a:xfrm>
           <a:prstGeom prst="roundRect">
@@ -53281,13 +56246,13 @@
       </p:sp>
       <p:sp>
         <p:nvSpPr>
-          <p:cNvPr id="33" name="TextBox 32"/>
+          <p:cNvPr id="35" name="TextBox 34"/>
           <p:cNvSpPr txBox="1"/>
           <p:nvPr/>
         </p:nvSpPr>
         <p:spPr>
           <a:xfrm>
-            <a:off x="502920" y="5166360"/>
+            <a:off x="502920" y="4617720"/>
             <a:ext cx="11185855" cy="274320"/>
           </a:xfrm>
           <a:prstGeom prst="rect">
@@ -53590,7 +56555,7 @@
                 </a:solidFill>
                 <a:latin typeface="Calibri"/>
               </a:rPr>
-              <a:t>8/63</a:t>
+              <a:t>8/65</a:t>
             </a:r>
           </a:p>
         </p:txBody>
@@ -54143,7 +57108,7 @@
                 </a:solidFill>
                 <a:latin typeface="Calibri"/>
               </a:rPr>
-              <a:t>9/63</a:t>
+              <a:t>9/65</a:t>
             </a:r>
           </a:p>
         </p:txBody>

</xml_diff>